<commit_message>
feat(tcc): adiciona slide com tabela-resumo REAL na apresentação principal
Helper add_table_resumo() cria tabela OOXML editável (paleta do deck). Novo slide
"Resumo dos Resultados — Núcleo de 4 Métodos" (slide 17) consolida os 6 achados:
HLM/mediação, Oaxaca de acesso (83,8/16,2), GLMM (OR 0,705->0,656, E-value>=2,2),
quantílica/RIF (sticky floor), interseccional (+9,5pp), robustez (R²=0,62).
Validado: deck com 21 slides, 1 tabela OOXML real 7x3 com conteúdo correto.

Co-Authored-By: Claude Opus 4.8 <noreply@anthropic.com>
</commit_message>
<xml_diff>
--- a/entregaveis/apresentacao_tcc.pptx
+++ b/entregaveis/apresentacao_tcc.pptx
@@ -25,6 +25,7 @@
     <p:sldId id="273" r:id="rId24"/>
     <p:sldId id="274" r:id="rId25"/>
     <p:sldId id="275" r:id="rId26"/>
+    <p:sldId id="276" r:id="rId27"/>
   </p:sldIdLst>
   <p:sldSz cx="12188952" cy="6858000" type="screen4x3"/>
   <p:notesSz cx="6858000" cy="9144000"/>
@@ -10357,7 +10358,7 @@
                 </a:solidFill>
                 <a:latin typeface="Calibri"/>
               </a:rPr>
-              <a:t>21. Síntese — Triângulo de Evidências</a:t>
+              <a:t>Resumo dos Resultados — Núcleo de 4 Métodos</a:t>
             </a:r>
           </a:p>
         </p:txBody>
@@ -10392,33 +10393,588 @@
                 </a:solidFill>
                 <a:latin typeface="Calibri"/>
               </a:rPr>
-              <a:t>Os métodos do núcleo apontam para o mesmo diagnóstico</a:t>
-            </a:r>
-          </a:p>
-        </p:txBody>
-      </p:sp>
-      <p:sp>
-        <p:nvSpPr>
-          <p:cNvPr id="5" name="Rectangle 4"/>
+              <a:t>Os quatro métodos convergem; a discriminação opera sobretudo no acesso às ocupações</a:t>
+            </a:r>
+          </a:p>
+        </p:txBody>
+      </p:sp>
+      <p:graphicFrame>
+        <p:nvGraphicFramePr>
+          <p:cNvPr id="5" name="Table 4"/>
+          <p:cNvGraphicFramePr>
+            <a:graphicFrameLocks noGrp="1"/>
+          </p:cNvGraphicFramePr>
+          <p:nvPr/>
+        </p:nvGraphicFramePr>
+        <p:xfrm>
+          <a:off x="365760" y="1234440"/>
+          <a:ext cx="11430000" cy="4480560"/>
+        </p:xfrm>
+        <a:graphic>
+          <a:graphicData uri="http://schemas.openxmlformats.org/drawingml/2006/table">
+            <a:tbl>
+              <a:tblPr firstRow="1" bandRow="1">
+                <a:tableStyleId>{5C22544A-7EE6-4342-B048-85BDC9FD1C3A}</a:tableStyleId>
+              </a:tblPr>
+              <a:tblGrid>
+                <a:gridCol w="2468880"/>
+                <a:gridCol w="2103120"/>
+                <a:gridCol w="6858000"/>
+              </a:tblGrid>
+              <a:tr h="640080">
+                <a:tc>
+                  <a:txBody>
+                    <a:bodyPr/>
+                    <a:lstStyle/>
+                    <a:p>
+                      <a:pPr algn="l"/>
+                      <a:r>
+                        <a:rPr b="1" sz="1200">
+                          <a:solidFill>
+                            <a:srgbClr val="FFFFFF"/>
+                          </a:solidFill>
+                          <a:latin typeface="Calibri"/>
+                        </a:rPr>
+                        <a:t>Dimensão</a:t>
+                      </a:r>
+                    </a:p>
+                  </a:txBody>
+                  <a:tcPr anchor="ctr">
+                    <a:solidFill>
+                      <a:srgbClr val="1F3864"/>
+                    </a:solidFill>
+                  </a:tcPr>
+                </a:tc>
+                <a:tc>
+                  <a:txBody>
+                    <a:bodyPr/>
+                    <a:lstStyle/>
+                    <a:p>
+                      <a:pPr algn="l"/>
+                      <a:r>
+                        <a:rPr b="1" sz="1200">
+                          <a:solidFill>
+                            <a:srgbClr val="FFFFFF"/>
+                          </a:solidFill>
+                          <a:latin typeface="Calibri"/>
+                        </a:rPr>
+                        <a:t>Método</a:t>
+                      </a:r>
+                    </a:p>
+                  </a:txBody>
+                  <a:tcPr anchor="ctr">
+                    <a:solidFill>
+                      <a:srgbClr val="1F3864"/>
+                    </a:solidFill>
+                  </a:tcPr>
+                </a:tc>
+                <a:tc>
+                  <a:txBody>
+                    <a:bodyPr/>
+                    <a:lstStyle/>
+                    <a:p>
+                      <a:pPr algn="l"/>
+                      <a:r>
+                        <a:rPr b="1" sz="1200">
+                          <a:solidFill>
+                            <a:srgbClr val="FFFFFF"/>
+                          </a:solidFill>
+                          <a:latin typeface="Calibri"/>
+                        </a:rPr>
+                        <a:t>Resultado-chave</a:t>
+                      </a:r>
+                    </a:p>
+                  </a:txBody>
+                  <a:tcPr anchor="ctr">
+                    <a:solidFill>
+                      <a:srgbClr val="1F3864"/>
+                    </a:solidFill>
+                  </a:tcPr>
+                </a:tc>
+              </a:tr>
+              <a:tr h="640080">
+                <a:tc>
+                  <a:txBody>
+                    <a:bodyPr/>
+                    <a:lstStyle/>
+                    <a:p>
+                      <a:pPr algn="l"/>
+                      <a:r>
+                        <a:rPr sz="1200" b="1">
+                          <a:solidFill>
+                            <a:srgbClr val="1F3864"/>
+                          </a:solidFill>
+                          <a:latin typeface="Calibri"/>
+                        </a:rPr>
+                        <a:t>Gap e mediação</a:t>
+                      </a:r>
+                    </a:p>
+                  </a:txBody>
+                  <a:tcPr anchor="ctr">
+                    <a:solidFill>
+                      <a:srgbClr val="FFFFFF"/>
+                    </a:solidFill>
+                  </a:tcPr>
+                </a:tc>
+                <a:tc>
+                  <a:txBody>
+                    <a:bodyPr/>
+                    <a:lstStyle/>
+                    <a:p>
+                      <a:pPr algn="l"/>
+                      <a:r>
+                        <a:rPr sz="1200">
+                          <a:solidFill>
+                            <a:srgbClr val="212121"/>
+                          </a:solidFill>
+                          <a:latin typeface="Calibri"/>
+                        </a:rPr>
+                        <a:t>HLM (3 níveis)</a:t>
+                      </a:r>
+                    </a:p>
+                  </a:txBody>
+                  <a:tcPr anchor="ctr">
+                    <a:solidFill>
+                      <a:srgbClr val="FFFFFF"/>
+                    </a:solidFill>
+                  </a:tcPr>
+                </a:tc>
+                <a:tc>
+                  <a:txBody>
+                    <a:bodyPr/>
+                    <a:lstStyle/>
+                    <a:p>
+                      <a:pPr algn="l"/>
+                      <a:r>
+                        <a:rPr sz="1200">
+                          <a:solidFill>
+                            <a:srgbClr val="212121"/>
+                          </a:solidFill>
+                          <a:latin typeface="Calibri"/>
+                        </a:rPr>
+                        <a:t>Gap −19,1% (M1) → −6,2% (M4); 69,8% mediado por contexto e ocupação</a:t>
+                      </a:r>
+                    </a:p>
+                  </a:txBody>
+                  <a:tcPr anchor="ctr">
+                    <a:solidFill>
+                      <a:srgbClr val="FFFFFF"/>
+                    </a:solidFill>
+                  </a:tcPr>
+                </a:tc>
+              </a:tr>
+              <a:tr h="640080">
+                <a:tc>
+                  <a:txBody>
+                    <a:bodyPr/>
+                    <a:lstStyle/>
+                    <a:p>
+                      <a:pPr algn="l"/>
+                      <a:r>
+                        <a:rPr sz="1200" b="1">
+                          <a:solidFill>
+                            <a:srgbClr val="1F3864"/>
+                          </a:solidFill>
+                          <a:latin typeface="Calibri"/>
+                        </a:rPr>
+                        <a:t>Composição × discriminação</a:t>
+                      </a:r>
+                    </a:p>
+                  </a:txBody>
+                  <a:tcPr anchor="ctr">
+                    <a:solidFill>
+                      <a:srgbClr val="F5F5F5"/>
+                    </a:solidFill>
+                  </a:tcPr>
+                </a:tc>
+                <a:tc>
+                  <a:txBody>
+                    <a:bodyPr/>
+                    <a:lstStyle/>
+                    <a:p>
+                      <a:pPr algn="l"/>
+                      <a:r>
+                        <a:rPr sz="1200">
+                          <a:solidFill>
+                            <a:srgbClr val="212121"/>
+                          </a:solidFill>
+                          <a:latin typeface="Calibri"/>
+                        </a:rPr>
+                        <a:t>Oaxaca-Blinder</a:t>
+                      </a:r>
+                    </a:p>
+                  </a:txBody>
+                  <a:tcPr anchor="ctr">
+                    <a:solidFill>
+                      <a:srgbClr val="F5F5F5"/>
+                    </a:solidFill>
+                  </a:tcPr>
+                </a:tc>
+                <a:tc>
+                  <a:txBody>
+                    <a:bodyPr/>
+                    <a:lstStyle/>
+                    <a:p>
+                      <a:pPr algn="l"/>
+                      <a:r>
+                        <a:rPr sz="1200">
+                          <a:solidFill>
+                            <a:srgbClr val="212121"/>
+                          </a:solidFill>
+                          <a:latin typeface="Calibri"/>
+                        </a:rPr>
+                        <a:t>83,8% dotações (acesso/composição) / 16,2% não explicado</a:t>
+                      </a:r>
+                    </a:p>
+                  </a:txBody>
+                  <a:tcPr anchor="ctr">
+                    <a:solidFill>
+                      <a:srgbClr val="F5F5F5"/>
+                    </a:solidFill>
+                  </a:tcPr>
+                </a:tc>
+              </a:tr>
+              <a:tr h="640080">
+                <a:tc>
+                  <a:txBody>
+                    <a:bodyPr/>
+                    <a:lstStyle/>
+                    <a:p>
+                      <a:pPr algn="l"/>
+                      <a:r>
+                        <a:rPr sz="1200" b="1">
+                          <a:solidFill>
+                            <a:srgbClr val="1F3864"/>
+                          </a:solidFill>
+                          <a:latin typeface="Calibri"/>
+                        </a:rPr>
+                        <a:t>Teto de vidro (acesso)</a:t>
+                      </a:r>
+                    </a:p>
+                  </a:txBody>
+                  <a:tcPr anchor="ctr">
+                    <a:solidFill>
+                      <a:srgbClr val="FFFFFF"/>
+                    </a:solidFill>
+                  </a:tcPr>
+                </a:tc>
+                <a:tc>
+                  <a:txBody>
+                    <a:bodyPr/>
+                    <a:lstStyle/>
+                    <a:p>
+                      <a:pPr algn="l"/>
+                      <a:r>
+                        <a:rPr sz="1200">
+                          <a:solidFill>
+                            <a:srgbClr val="212121"/>
+                          </a:solidFill>
+                          <a:latin typeface="Calibri"/>
+                        </a:rPr>
+                        <a:t>GLMM logístico</a:t>
+                      </a:r>
+                    </a:p>
+                  </a:txBody>
+                  <a:tcPr anchor="ctr">
+                    <a:solidFill>
+                      <a:srgbClr val="FFFFFF"/>
+                    </a:solidFill>
+                  </a:tcPr>
+                </a:tc>
+                <a:tc>
+                  <a:txBody>
+                    <a:bodyPr/>
+                    <a:lstStyle/>
+                    <a:p>
+                      <a:pPr algn="l"/>
+                      <a:r>
+                        <a:rPr sz="1200">
+                          <a:solidFill>
+                            <a:srgbClr val="212121"/>
+                          </a:solidFill>
+                          <a:latin typeface="Calibri"/>
+                        </a:rPr>
+                        <a:t>OR 0,705 (cargo qualif.) → 0,656 (top 10%); E-value ≥ 2,2</a:t>
+                      </a:r>
+                    </a:p>
+                  </a:txBody>
+                  <a:tcPr anchor="ctr">
+                    <a:solidFill>
+                      <a:srgbClr val="FFFFFF"/>
+                    </a:solidFill>
+                  </a:tcPr>
+                </a:tc>
+              </a:tr>
+              <a:tr h="640080">
+                <a:tc>
+                  <a:txBody>
+                    <a:bodyPr/>
+                    <a:lstStyle/>
+                    <a:p>
+                      <a:pPr algn="l"/>
+                      <a:r>
+                        <a:rPr sz="1200" b="1">
+                          <a:solidFill>
+                            <a:srgbClr val="1F3864"/>
+                          </a:solidFill>
+                          <a:latin typeface="Calibri"/>
+                        </a:rPr>
+                        <a:t>Distribuição da renda</a:t>
+                      </a:r>
+                    </a:p>
+                  </a:txBody>
+                  <a:tcPr anchor="ctr">
+                    <a:solidFill>
+                      <a:srgbClr val="F5F5F5"/>
+                    </a:solidFill>
+                  </a:tcPr>
+                </a:tc>
+                <a:tc>
+                  <a:txBody>
+                    <a:bodyPr/>
+                    <a:lstStyle/>
+                    <a:p>
+                      <a:pPr algn="l"/>
+                      <a:r>
+                        <a:rPr sz="1200">
+                          <a:solidFill>
+                            <a:srgbClr val="212121"/>
+                          </a:solidFill>
+                          <a:latin typeface="Calibri"/>
+                        </a:rPr>
+                        <a:t>Quantílica / RIF</a:t>
+                      </a:r>
+                    </a:p>
+                  </a:txBody>
+                  <a:tcPr anchor="ctr">
+                    <a:solidFill>
+                      <a:srgbClr val="F5F5F5"/>
+                    </a:solidFill>
+                  </a:tcPr>
+                </a:tc>
+                <a:tc>
+                  <a:txBody>
+                    <a:bodyPr/>
+                    <a:lstStyle/>
+                    <a:p>
+                      <a:pPr algn="l"/>
+                      <a:r>
+                        <a:rPr sz="1200">
+                          <a:solidFill>
+                            <a:srgbClr val="212121"/>
+                          </a:solidFill>
+                          <a:latin typeface="Calibri"/>
+                        </a:rPr>
+                        <a:t>Gap −8,0% (q10) → −12,3% (q95); sticky floor: retornos 35% → 13%</a:t>
+                      </a:r>
+                    </a:p>
+                  </a:txBody>
+                  <a:tcPr anchor="ctr">
+                    <a:solidFill>
+                      <a:srgbClr val="F5F5F5"/>
+                    </a:solidFill>
+                  </a:tcPr>
+                </a:tc>
+              </a:tr>
+              <a:tr h="640080">
+                <a:tc>
+                  <a:txBody>
+                    <a:bodyPr/>
+                    <a:lstStyle/>
+                    <a:p>
+                      <a:pPr algn="l"/>
+                      <a:r>
+                        <a:rPr sz="1200" b="1">
+                          <a:solidFill>
+                            <a:srgbClr val="1F3864"/>
+                          </a:solidFill>
+                          <a:latin typeface="Calibri"/>
+                        </a:rPr>
+                        <a:t>Interseccionalidade</a:t>
+                      </a:r>
+                    </a:p>
+                  </a:txBody>
+                  <a:tcPr anchor="ctr">
+                    <a:solidFill>
+                      <a:srgbClr val="FFFFFF"/>
+                    </a:solidFill>
+                  </a:tcPr>
+                </a:tc>
+                <a:tc>
+                  <a:txBody>
+                    <a:bodyPr/>
+                    <a:lstStyle/>
+                    <a:p>
+                      <a:pPr algn="l"/>
+                      <a:r>
+                        <a:rPr sz="1200">
+                          <a:solidFill>
+                            <a:srgbClr val="212121"/>
+                          </a:solidFill>
+                          <a:latin typeface="Calibri"/>
+                        </a:rPr>
+                        <a:t>Oaxaca 4 grupos</a:t>
+                      </a:r>
+                    </a:p>
+                  </a:txBody>
+                  <a:tcPr anchor="ctr">
+                    <a:solidFill>
+                      <a:srgbClr val="FFFFFF"/>
+                    </a:solidFill>
+                  </a:tcPr>
+                </a:tc>
+                <a:tc>
+                  <a:txBody>
+                    <a:bodyPr/>
+                    <a:lstStyle/>
+                    <a:p>
+                      <a:pPr algn="l"/>
+                      <a:r>
+                        <a:rPr sz="1200">
+                          <a:solidFill>
+                            <a:srgbClr val="212121"/>
+                          </a:solidFill>
+                          <a:latin typeface="Calibri"/>
+                        </a:rPr>
+                        <a:t>Mulher Negra: gap 96,4%; penalidade extra +9,5 p.p. (não-aditiva)</a:t>
+                      </a:r>
+                    </a:p>
+                  </a:txBody>
+                  <a:tcPr anchor="ctr">
+                    <a:solidFill>
+                      <a:srgbClr val="FFFFFF"/>
+                    </a:solidFill>
+                  </a:tcPr>
+                </a:tc>
+              </a:tr>
+              <a:tr h="640080">
+                <a:tc>
+                  <a:txBody>
+                    <a:bodyPr/>
+                    <a:lstStyle/>
+                    <a:p>
+                      <a:pPr algn="l"/>
+                      <a:r>
+                        <a:rPr sz="1200" b="1">
+                          <a:solidFill>
+                            <a:srgbClr val="1F3864"/>
+                          </a:solidFill>
+                          <a:latin typeface="Calibri"/>
+                        </a:rPr>
+                        <a:t>Robustez</a:t>
+                      </a:r>
+                    </a:p>
+                  </a:txBody>
+                  <a:tcPr anchor="ctr">
+                    <a:solidFill>
+                      <a:srgbClr val="F5F5F5"/>
+                    </a:solidFill>
+                  </a:tcPr>
+                </a:tc>
+                <a:tc>
+                  <a:txBody>
+                    <a:bodyPr/>
+                    <a:lstStyle/>
+                    <a:p>
+                      <a:pPr algn="l"/>
+                      <a:r>
+                        <a:rPr sz="1200">
+                          <a:solidFill>
+                            <a:srgbClr val="212121"/>
+                          </a:solidFill>
+                          <a:latin typeface="Calibri"/>
+                        </a:rPr>
+                        <a:t>XGBoost + SHAP / E-value</a:t>
+                      </a:r>
+                    </a:p>
+                  </a:txBody>
+                  <a:tcPr anchor="ctr">
+                    <a:solidFill>
+                      <a:srgbClr val="F5F5F5"/>
+                    </a:solidFill>
+                  </a:tcPr>
+                </a:tc>
+                <a:tc>
+                  <a:txBody>
+                    <a:bodyPr/>
+                    <a:lstStyle/>
+                    <a:p>
+                      <a:pPr algn="l"/>
+                      <a:r>
+                        <a:rPr sz="1200">
+                          <a:solidFill>
+                            <a:srgbClr val="212121"/>
+                          </a:solidFill>
+                          <a:latin typeface="Calibri"/>
+                        </a:rPr>
+                        <a:t>R²=0,62; raça com efeito residual após controles; sem sobreajuste</a:t>
+                      </a:r>
+                    </a:p>
+                  </a:txBody>
+                  <a:tcPr anchor="ctr">
+                    <a:solidFill>
+                      <a:srgbClr val="F5F5F5"/>
+                    </a:solidFill>
+                  </a:tcPr>
+                </a:tc>
+              </a:tr>
+            </a:tbl>
+          </a:graphicData>
+        </a:graphic>
+      </p:graphicFrame>
+      <p:sp>
+        <p:nvSpPr>
+          <p:cNvPr id="6" name="TextBox 5"/>
+          <p:cNvSpPr txBox="1"/>
+          <p:nvPr/>
+        </p:nvSpPr>
+        <p:spPr>
+          <a:xfrm>
+            <a:off x="365760" y="5943600"/>
+            <a:ext cx="11430000" cy="457200"/>
+          </a:xfrm>
+          <a:prstGeom prst="rect">
+            <a:avLst/>
+          </a:prstGeom>
+          <a:noFill/>
+        </p:spPr>
+        <p:txBody>
+          <a:bodyPr wrap="square">
+            <a:spAutoFit/>
+          </a:bodyPr>
+          <a:lstStyle/>
+          <a:p>
+            <a:pPr algn="l"/>
+            <a:r>
+              <a:rPr sz="1100" b="0" i="1">
+                <a:solidFill>
+                  <a:srgbClr val="616161"/>
+                </a:solidFill>
+                <a:latin typeface="Calibri"/>
+              </a:rPr>
+              <a:t>Leitura: cada linha é um método independente respondendo uma pergunta distinta; OR &lt; 1 indica menor acesso para negros de mesmo perfil.</a:t>
+            </a:r>
+          </a:p>
+        </p:txBody>
+      </p:sp>
+      <p:sp>
+        <p:nvSpPr>
+          <p:cNvPr id="7" name="Rectangle 6"/>
           <p:cNvSpPr/>
           <p:nvPr/>
         </p:nvSpPr>
         <p:spPr>
           <a:xfrm>
-            <a:off x="274320" y="1188720"/>
-            <a:ext cx="5303520" cy="2377440"/>
+            <a:off x="0" y="6601968"/>
+            <a:ext cx="12188952" cy="256032"/>
           </a:xfrm>
           <a:prstGeom prst="rect">
             <a:avLst/>
           </a:prstGeom>
           <a:solidFill>
-            <a:srgbClr val="F5F5F5"/>
+            <a:srgbClr val="1F3864"/>
           </a:solidFill>
-          <a:ln w="19050">
-            <a:solidFill>
-              <a:srgbClr val="B71C1C"/>
-            </a:solidFill>
-          </a:ln>
+          <a:ln/>
         </p:spPr>
         <p:style>
           <a:lnRef idx="1">
@@ -10444,760 +11000,7 @@
       </p:sp>
       <p:sp>
         <p:nvSpPr>
-          <p:cNvPr id="6" name="Rectangle 5"/>
-          <p:cNvSpPr/>
-          <p:nvPr/>
-        </p:nvSpPr>
-        <p:spPr>
-          <a:xfrm>
-            <a:off x="274320" y="1188720"/>
-            <a:ext cx="5303520" cy="457200"/>
-          </a:xfrm>
-          <a:prstGeom prst="rect">
-            <a:avLst/>
-          </a:prstGeom>
-          <a:solidFill>
-            <a:srgbClr val="B71C1C"/>
-          </a:solidFill>
-          <a:ln/>
-        </p:spPr>
-        <p:style>
-          <a:lnRef idx="1">
-            <a:schemeClr val="accent1"/>
-          </a:lnRef>
-          <a:fillRef idx="3">
-            <a:schemeClr val="accent1"/>
-          </a:fillRef>
-          <a:effectRef idx="2">
-            <a:schemeClr val="accent1"/>
-          </a:effectRef>
-          <a:fontRef idx="minor">
-            <a:schemeClr val="lt1"/>
-          </a:fontRef>
-        </p:style>
-        <p:txBody>
-          <a:bodyPr rtlCol="0" anchor="ctr"/>
-          <a:lstStyle/>
-          <a:p>
-            <a:pPr algn="ctr"/>
-          </a:p>
-        </p:txBody>
-      </p:sp>
-      <p:sp>
-        <p:nvSpPr>
-          <p:cNvPr id="7" name="TextBox 6"/>
-          <p:cNvSpPr txBox="1"/>
-          <p:nvPr/>
-        </p:nvSpPr>
-        <p:spPr>
-          <a:xfrm>
-            <a:off x="365760" y="1234440"/>
-            <a:ext cx="5120640" cy="411480"/>
-          </a:xfrm>
-          <a:prstGeom prst="rect">
-            <a:avLst/>
-          </a:prstGeom>
-          <a:noFill/>
-        </p:spPr>
-        <p:txBody>
-          <a:bodyPr wrap="square">
-            <a:spAutoFit/>
-          </a:bodyPr>
-          <a:lstStyle/>
-          <a:p>
-            <a:pPr algn="ctr"/>
-            <a:r>
-              <a:rPr sz="1300" b="1" i="0">
-                <a:solidFill>
-                  <a:srgbClr val="FFFFFF"/>
-                </a:solidFill>
-                <a:latin typeface="Calibri"/>
-              </a:rPr>
-              <a:t>DISCRIMINAÇÃO
-DE ACESSO</a:t>
-            </a:r>
-          </a:p>
-        </p:txBody>
-      </p:sp>
-      <p:sp>
-        <p:nvSpPr>
           <p:cNvPr id="8" name="TextBox 7"/>
-          <p:cNvSpPr txBox="1"/>
-          <p:nvPr/>
-        </p:nvSpPr>
-        <p:spPr>
-          <a:xfrm>
-            <a:off x="457200" y="1737360"/>
-            <a:ext cx="4937760" cy="502920"/>
-          </a:xfrm>
-          <a:prstGeom prst="rect">
-            <a:avLst/>
-          </a:prstGeom>
-          <a:noFill/>
-        </p:spPr>
-        <p:txBody>
-          <a:bodyPr wrap="square">
-            <a:spAutoFit/>
-          </a:bodyPr>
-          <a:lstStyle/>
-          <a:p>
-            <a:pPr algn="l"/>
-            <a:r>
-              <a:rPr sz="1200" b="0" i="0">
-                <a:solidFill>
-                  <a:srgbClr val="212121"/>
-                </a:solidFill>
-                <a:latin typeface="Calibri"/>
-              </a:rPr>
-              <a:t>• GLMM: OR=0,693 para ocp. qualificada</a:t>
-            </a:r>
-          </a:p>
-        </p:txBody>
-      </p:sp>
-      <p:sp>
-        <p:nvSpPr>
-          <p:cNvPr id="9" name="TextBox 8"/>
-          <p:cNvSpPr txBox="1"/>
-          <p:nvPr/>
-        </p:nvSpPr>
-        <p:spPr>
-          <a:xfrm>
-            <a:off x="457200" y="2286000"/>
-            <a:ext cx="4937760" cy="502920"/>
-          </a:xfrm>
-          <a:prstGeom prst="rect">
-            <a:avLst/>
-          </a:prstGeom>
-          <a:noFill/>
-        </p:spPr>
-        <p:txBody>
-          <a:bodyPr wrap="square">
-            <a:spAutoFit/>
-          </a:bodyPr>
-          <a:lstStyle/>
-          <a:p>
-            <a:pPr algn="l"/>
-            <a:r>
-              <a:rPr sz="1200" b="0" i="0">
-                <a:solidFill>
-                  <a:srgbClr val="212121"/>
-                </a:solidFill>
-                <a:latin typeface="Calibri"/>
-              </a:rPr>
-              <a:t>• AME=−4,73 p.p. residual (M2)</a:t>
-            </a:r>
-          </a:p>
-        </p:txBody>
-      </p:sp>
-      <p:sp>
-        <p:nvSpPr>
-          <p:cNvPr id="10" name="TextBox 9"/>
-          <p:cNvSpPr txBox="1"/>
-          <p:nvPr/>
-        </p:nvSpPr>
-        <p:spPr>
-          <a:xfrm>
-            <a:off x="457200" y="2834640"/>
-            <a:ext cx="4937760" cy="502920"/>
-          </a:xfrm>
-          <a:prstGeom prst="rect">
-            <a:avLst/>
-          </a:prstGeom>
-          <a:noFill/>
-        </p:spPr>
-        <p:txBody>
-          <a:bodyPr wrap="square">
-            <a:spAutoFit/>
-          </a:bodyPr>
-          <a:lstStyle/>
-          <a:p>
-            <a:pPr algn="l"/>
-            <a:r>
-              <a:rPr sz="1200" b="0" i="0">
-                <a:solidFill>
-                  <a:srgbClr val="212121"/>
-                </a:solidFill>
-                <a:latin typeface="Calibri"/>
-              </a:rPr>
-              <a:t>• Persiste após todos os controles observáveis</a:t>
-            </a:r>
-          </a:p>
-        </p:txBody>
-      </p:sp>
-      <p:sp>
-        <p:nvSpPr>
-          <p:cNvPr id="11" name="Rectangle 10"/>
-          <p:cNvSpPr/>
-          <p:nvPr/>
-        </p:nvSpPr>
-        <p:spPr>
-          <a:xfrm>
-            <a:off x="6309360" y="1188720"/>
-            <a:ext cx="5303520" cy="2377440"/>
-          </a:xfrm>
-          <a:prstGeom prst="rect">
-            <a:avLst/>
-          </a:prstGeom>
-          <a:solidFill>
-            <a:srgbClr val="F5F5F5"/>
-          </a:solidFill>
-          <a:ln w="19050">
-            <a:solidFill>
-              <a:srgbClr val="1565C0"/>
-            </a:solidFill>
-          </a:ln>
-        </p:spPr>
-        <p:style>
-          <a:lnRef idx="1">
-            <a:schemeClr val="accent1"/>
-          </a:lnRef>
-          <a:fillRef idx="3">
-            <a:schemeClr val="accent1"/>
-          </a:fillRef>
-          <a:effectRef idx="2">
-            <a:schemeClr val="accent1"/>
-          </a:effectRef>
-          <a:fontRef idx="minor">
-            <a:schemeClr val="lt1"/>
-          </a:fontRef>
-        </p:style>
-        <p:txBody>
-          <a:bodyPr rtlCol="0" anchor="ctr"/>
-          <a:lstStyle/>
-          <a:p>
-            <a:pPr algn="ctr"/>
-          </a:p>
-        </p:txBody>
-      </p:sp>
-      <p:sp>
-        <p:nvSpPr>
-          <p:cNvPr id="12" name="Rectangle 11"/>
-          <p:cNvSpPr/>
-          <p:nvPr/>
-        </p:nvSpPr>
-        <p:spPr>
-          <a:xfrm>
-            <a:off x="6309360" y="1188720"/>
-            <a:ext cx="5303520" cy="457200"/>
-          </a:xfrm>
-          <a:prstGeom prst="rect">
-            <a:avLst/>
-          </a:prstGeom>
-          <a:solidFill>
-            <a:srgbClr val="1565C0"/>
-          </a:solidFill>
-          <a:ln/>
-        </p:spPr>
-        <p:style>
-          <a:lnRef idx="1">
-            <a:schemeClr val="accent1"/>
-          </a:lnRef>
-          <a:fillRef idx="3">
-            <a:schemeClr val="accent1"/>
-          </a:fillRef>
-          <a:effectRef idx="2">
-            <a:schemeClr val="accent1"/>
-          </a:effectRef>
-          <a:fontRef idx="minor">
-            <a:schemeClr val="lt1"/>
-          </a:fontRef>
-        </p:style>
-        <p:txBody>
-          <a:bodyPr rtlCol="0" anchor="ctr"/>
-          <a:lstStyle/>
-          <a:p>
-            <a:pPr algn="ctr"/>
-          </a:p>
-        </p:txBody>
-      </p:sp>
-      <p:sp>
-        <p:nvSpPr>
-          <p:cNvPr id="13" name="TextBox 12"/>
-          <p:cNvSpPr txBox="1"/>
-          <p:nvPr/>
-        </p:nvSpPr>
-        <p:spPr>
-          <a:xfrm>
-            <a:off x="6400800" y="1234440"/>
-            <a:ext cx="5120640" cy="411480"/>
-          </a:xfrm>
-          <a:prstGeom prst="rect">
-            <a:avLst/>
-          </a:prstGeom>
-          <a:noFill/>
-        </p:spPr>
-        <p:txBody>
-          <a:bodyPr wrap="square">
-            <a:spAutoFit/>
-          </a:bodyPr>
-          <a:lstStyle/>
-          <a:p>
-            <a:pPr algn="ctr"/>
-            <a:r>
-              <a:rPr sz="1300" b="1" i="0">
-                <a:solidFill>
-                  <a:srgbClr val="FFFFFF"/>
-                </a:solidFill>
-                <a:latin typeface="Calibri"/>
-              </a:rPr>
-              <a:t>DISCRIMINAÇÃO
-DE REMUNERAÇÃO</a:t>
-            </a:r>
-          </a:p>
-        </p:txBody>
-      </p:sp>
-      <p:sp>
-        <p:nvSpPr>
-          <p:cNvPr id="14" name="TextBox 13"/>
-          <p:cNvSpPr txBox="1"/>
-          <p:nvPr/>
-        </p:nvSpPr>
-        <p:spPr>
-          <a:xfrm>
-            <a:off x="6492240" y="1737360"/>
-            <a:ext cx="4937760" cy="502920"/>
-          </a:xfrm>
-          <a:prstGeom prst="rect">
-            <a:avLst/>
-          </a:prstGeom>
-          <a:noFill/>
-        </p:spPr>
-        <p:txBody>
-          <a:bodyPr wrap="square">
-            <a:spAutoFit/>
-          </a:bodyPr>
-          <a:lstStyle/>
-          <a:p>
-            <a:pPr algn="l"/>
-            <a:r>
-              <a:rPr sz="1200" b="0" i="0">
-                <a:solidFill>
-                  <a:srgbClr val="212121"/>
-                </a:solidFill>
-                <a:latin typeface="Calibri"/>
-              </a:rPr>
-              <a:t>• HLM M4: gap residual 6,2%</a:t>
-            </a:r>
-          </a:p>
-        </p:txBody>
-      </p:sp>
-      <p:sp>
-        <p:nvSpPr>
-          <p:cNvPr id="15" name="TextBox 14"/>
-          <p:cNvSpPr txBox="1"/>
-          <p:nvPr/>
-        </p:nvSpPr>
-        <p:spPr>
-          <a:xfrm>
-            <a:off x="6492240" y="2286000"/>
-            <a:ext cx="4937760" cy="502920"/>
-          </a:xfrm>
-          <a:prstGeom prst="rect">
-            <a:avLst/>
-          </a:prstGeom>
-          <a:noFill/>
-        </p:spPr>
-        <p:txBody>
-          <a:bodyPr wrap="square">
-            <a:spAutoFit/>
-          </a:bodyPr>
-          <a:lstStyle/>
-          <a:p>
-            <a:pPr algn="l"/>
-            <a:r>
-              <a:rPr sz="1200" b="0" i="0">
-                <a:solidFill>
-                  <a:srgbClr val="212121"/>
-                </a:solidFill>
-                <a:latin typeface="Calibri"/>
-              </a:rPr>
-              <a:t>• Quantile Reg.: cresce no topo (glass ceiling)</a:t>
-            </a:r>
-          </a:p>
-        </p:txBody>
-      </p:sp>
-      <p:sp>
-        <p:nvSpPr>
-          <p:cNvPr id="16" name="TextBox 15"/>
-          <p:cNvSpPr txBox="1"/>
-          <p:nvPr/>
-        </p:nvSpPr>
-        <p:spPr>
-          <a:xfrm>
-            <a:off x="6492240" y="2834640"/>
-            <a:ext cx="4937760" cy="502920"/>
-          </a:xfrm>
-          <a:prstGeom prst="rect">
-            <a:avLst/>
-          </a:prstGeom>
-          <a:noFill/>
-        </p:spPr>
-        <p:txBody>
-          <a:bodyPr wrap="square">
-            <a:spAutoFit/>
-          </a:bodyPr>
-          <a:lstStyle/>
-          <a:p>
-            <a:pPr algn="l"/>
-            <a:r>
-              <a:rPr sz="1200" b="0" i="0">
-                <a:solidFill>
-                  <a:srgbClr val="212121"/>
-                </a:solidFill>
-                <a:latin typeface="Calibri"/>
-              </a:rPr>
-              <a:t>• SHAP: −2,5% efeito racial residual</a:t>
-            </a:r>
-          </a:p>
-        </p:txBody>
-      </p:sp>
-      <p:sp>
-        <p:nvSpPr>
-          <p:cNvPr id="17" name="Rectangle 16"/>
-          <p:cNvSpPr/>
-          <p:nvPr/>
-        </p:nvSpPr>
-        <p:spPr>
-          <a:xfrm>
-            <a:off x="3291840" y="3931920"/>
-            <a:ext cx="5303520" cy="2377440"/>
-          </a:xfrm>
-          <a:prstGeom prst="rect">
-            <a:avLst/>
-          </a:prstGeom>
-          <a:solidFill>
-            <a:srgbClr val="F5F5F5"/>
-          </a:solidFill>
-          <a:ln w="19050">
-            <a:solidFill>
-              <a:srgbClr val="1F3864"/>
-            </a:solidFill>
-          </a:ln>
-        </p:spPr>
-        <p:style>
-          <a:lnRef idx="1">
-            <a:schemeClr val="accent1"/>
-          </a:lnRef>
-          <a:fillRef idx="3">
-            <a:schemeClr val="accent1"/>
-          </a:fillRef>
-          <a:effectRef idx="2">
-            <a:schemeClr val="accent1"/>
-          </a:effectRef>
-          <a:fontRef idx="minor">
-            <a:schemeClr val="lt1"/>
-          </a:fontRef>
-        </p:style>
-        <p:txBody>
-          <a:bodyPr rtlCol="0" anchor="ctr"/>
-          <a:lstStyle/>
-          <a:p>
-            <a:pPr algn="ctr"/>
-          </a:p>
-        </p:txBody>
-      </p:sp>
-      <p:sp>
-        <p:nvSpPr>
-          <p:cNvPr id="18" name="Rectangle 17"/>
-          <p:cNvSpPr/>
-          <p:nvPr/>
-        </p:nvSpPr>
-        <p:spPr>
-          <a:xfrm>
-            <a:off x="3291840" y="3931920"/>
-            <a:ext cx="5303520" cy="457200"/>
-          </a:xfrm>
-          <a:prstGeom prst="rect">
-            <a:avLst/>
-          </a:prstGeom>
-          <a:solidFill>
-            <a:srgbClr val="1F3864"/>
-          </a:solidFill>
-          <a:ln/>
-        </p:spPr>
-        <p:style>
-          <a:lnRef idx="1">
-            <a:schemeClr val="accent1"/>
-          </a:lnRef>
-          <a:fillRef idx="3">
-            <a:schemeClr val="accent1"/>
-          </a:fillRef>
-          <a:effectRef idx="2">
-            <a:schemeClr val="accent1"/>
-          </a:effectRef>
-          <a:fontRef idx="minor">
-            <a:schemeClr val="lt1"/>
-          </a:fontRef>
-        </p:style>
-        <p:txBody>
-          <a:bodyPr rtlCol="0" anchor="ctr"/>
-          <a:lstStyle/>
-          <a:p>
-            <a:pPr algn="ctr"/>
-          </a:p>
-        </p:txBody>
-      </p:sp>
-      <p:sp>
-        <p:nvSpPr>
-          <p:cNvPr id="19" name="TextBox 18"/>
-          <p:cNvSpPr txBox="1"/>
-          <p:nvPr/>
-        </p:nvSpPr>
-        <p:spPr>
-          <a:xfrm>
-            <a:off x="3383280" y="3977640"/>
-            <a:ext cx="5120640" cy="411480"/>
-          </a:xfrm>
-          <a:prstGeom prst="rect">
-            <a:avLst/>
-          </a:prstGeom>
-          <a:noFill/>
-        </p:spPr>
-        <p:txBody>
-          <a:bodyPr wrap="square">
-            <a:spAutoFit/>
-          </a:bodyPr>
-          <a:lstStyle/>
-          <a:p>
-            <a:pPr algn="ctr"/>
-            <a:r>
-              <a:rPr sz="1300" b="1" i="0">
-                <a:solidFill>
-                  <a:srgbClr val="FFFFFF"/>
-                </a:solidFill>
-                <a:latin typeface="Calibri"/>
-              </a:rPr>
-              <a:t>PENALIDADE
-INTERSECCIONAL</a:t>
-            </a:r>
-          </a:p>
-        </p:txBody>
-      </p:sp>
-      <p:sp>
-        <p:nvSpPr>
-          <p:cNvPr id="20" name="TextBox 19"/>
-          <p:cNvSpPr txBox="1"/>
-          <p:nvPr/>
-        </p:nvSpPr>
-        <p:spPr>
-          <a:xfrm>
-            <a:off x="3474720" y="4480560"/>
-            <a:ext cx="4937760" cy="502920"/>
-          </a:xfrm>
-          <a:prstGeom prst="rect">
-            <a:avLst/>
-          </a:prstGeom>
-          <a:noFill/>
-        </p:spPr>
-        <p:txBody>
-          <a:bodyPr wrap="square">
-            <a:spAutoFit/>
-          </a:bodyPr>
-          <a:lstStyle/>
-          <a:p>
-            <a:pPr algn="l"/>
-            <a:r>
-              <a:rPr sz="1200" b="0" i="0">
-                <a:solidFill>
-                  <a:srgbClr val="212121"/>
-                </a:solidFill>
-                <a:latin typeface="Calibri"/>
-              </a:rPr>
-              <a:t>• Mulher Negra: gap de 96,4%</a:t>
-            </a:r>
-          </a:p>
-        </p:txBody>
-      </p:sp>
-      <p:sp>
-        <p:nvSpPr>
-          <p:cNvPr id="21" name="TextBox 20"/>
-          <p:cNvSpPr txBox="1"/>
-          <p:nvPr/>
-        </p:nvSpPr>
-        <p:spPr>
-          <a:xfrm>
-            <a:off x="3474720" y="5029200"/>
-            <a:ext cx="4937760" cy="502920"/>
-          </a:xfrm>
-          <a:prstGeom prst="rect">
-            <a:avLst/>
-          </a:prstGeom>
-          <a:noFill/>
-        </p:spPr>
-        <p:txBody>
-          <a:bodyPr wrap="square">
-            <a:spAutoFit/>
-          </a:bodyPr>
-          <a:lstStyle/>
-          <a:p>
-            <a:pPr algn="l"/>
-            <a:r>
-              <a:rPr sz="1200" b="0" i="0">
-                <a:solidFill>
-                  <a:srgbClr val="212121"/>
-                </a:solidFill>
-                <a:latin typeface="Calibri"/>
-              </a:rPr>
-              <a:t>• Penalidade extra de +9,5 p.p. (não-aditiva)</a:t>
-            </a:r>
-          </a:p>
-        </p:txBody>
-      </p:sp>
-      <p:sp>
-        <p:nvSpPr>
-          <p:cNvPr id="22" name="TextBox 21"/>
-          <p:cNvSpPr txBox="1"/>
-          <p:nvPr/>
-        </p:nvSpPr>
-        <p:spPr>
-          <a:xfrm>
-            <a:off x="3474720" y="5577840"/>
-            <a:ext cx="4937760" cy="502920"/>
-          </a:xfrm>
-          <a:prstGeom prst="rect">
-            <a:avLst/>
-          </a:prstGeom>
-          <a:noFill/>
-        </p:spPr>
-        <p:txBody>
-          <a:bodyPr wrap="square">
-            <a:spAutoFit/>
-          </a:bodyPr>
-          <a:lstStyle/>
-          <a:p>
-            <a:pPr algn="l"/>
-            <a:r>
-              <a:rPr sz="1200" b="0" i="0">
-                <a:solidFill>
-                  <a:srgbClr val="212121"/>
-                </a:solidFill>
-                <a:latin typeface="Calibri"/>
-              </a:rPr>
-              <a:t>• Raça×gênero como mecanismo próprio (Crenshaw)</a:t>
-            </a:r>
-          </a:p>
-        </p:txBody>
-      </p:sp>
-      <p:sp>
-        <p:nvSpPr>
-          <p:cNvPr id="23" name="Rectangle 22"/>
-          <p:cNvSpPr/>
-          <p:nvPr/>
-        </p:nvSpPr>
-        <p:spPr>
-          <a:xfrm>
-            <a:off x="274320" y="5852160"/>
-            <a:ext cx="11612880" cy="457200"/>
-          </a:xfrm>
-          <a:prstGeom prst="rect">
-            <a:avLst/>
-          </a:prstGeom>
-          <a:solidFill>
-            <a:srgbClr val="1F3864"/>
-          </a:solidFill>
-          <a:ln/>
-        </p:spPr>
-        <p:style>
-          <a:lnRef idx="1">
-            <a:schemeClr val="accent1"/>
-          </a:lnRef>
-          <a:fillRef idx="3">
-            <a:schemeClr val="accent1"/>
-          </a:fillRef>
-          <a:effectRef idx="2">
-            <a:schemeClr val="accent1"/>
-          </a:effectRef>
-          <a:fontRef idx="minor">
-            <a:schemeClr val="lt1"/>
-          </a:fontRef>
-        </p:style>
-        <p:txBody>
-          <a:bodyPr rtlCol="0" anchor="ctr"/>
-          <a:lstStyle/>
-          <a:p>
-            <a:pPr algn="ctr"/>
-          </a:p>
-        </p:txBody>
-      </p:sp>
-      <p:sp>
-        <p:nvSpPr>
-          <p:cNvPr id="24" name="TextBox 23"/>
-          <p:cNvSpPr txBox="1"/>
-          <p:nvPr/>
-        </p:nvSpPr>
-        <p:spPr>
-          <a:xfrm>
-            <a:off x="457200" y="5897880"/>
-            <a:ext cx="11247120" cy="411480"/>
-          </a:xfrm>
-          <a:prstGeom prst="rect">
-            <a:avLst/>
-          </a:prstGeom>
-          <a:noFill/>
-        </p:spPr>
-        <p:txBody>
-          <a:bodyPr wrap="square">
-            <a:spAutoFit/>
-          </a:bodyPr>
-          <a:lstStyle/>
-          <a:p>
-            <a:pPr algn="ctr"/>
-            <a:r>
-              <a:rPr sz="1200" b="1" i="0">
-                <a:solidFill>
-                  <a:srgbClr val="FFFFFF"/>
-                </a:solidFill>
-                <a:latin typeface="Calibri"/>
-              </a:rPr>
-              <a:t>Oaxaca: 83,8% do gap é composição/ACESSO e 16,2% remuneração | GLMM mostra a barreira de acesso (OR=0,705) | RIF: discriminação de preço maior na base (sticky floor)</a:t>
-            </a:r>
-          </a:p>
-        </p:txBody>
-      </p:sp>
-      <p:sp>
-        <p:nvSpPr>
-          <p:cNvPr id="25" name="Rectangle 24"/>
-          <p:cNvSpPr/>
-          <p:nvPr/>
-        </p:nvSpPr>
-        <p:spPr>
-          <a:xfrm>
-            <a:off x="0" y="6601968"/>
-            <a:ext cx="12188952" cy="256032"/>
-          </a:xfrm>
-          <a:prstGeom prst="rect">
-            <a:avLst/>
-          </a:prstGeom>
-          <a:solidFill>
-            <a:srgbClr val="1F3864"/>
-          </a:solidFill>
-          <a:ln/>
-        </p:spPr>
-        <p:style>
-          <a:lnRef idx="1">
-            <a:schemeClr val="accent1"/>
-          </a:lnRef>
-          <a:fillRef idx="3">
-            <a:schemeClr val="accent1"/>
-          </a:fillRef>
-          <a:effectRef idx="2">
-            <a:schemeClr val="accent1"/>
-          </a:effectRef>
-          <a:fontRef idx="minor">
-            <a:schemeClr val="lt1"/>
-          </a:fontRef>
-        </p:style>
-        <p:txBody>
-          <a:bodyPr rtlCol="0" anchor="ctr"/>
-          <a:lstStyle/>
-          <a:p>
-            <a:pPr algn="ctr"/>
-          </a:p>
-        </p:txBody>
-      </p:sp>
-      <p:sp>
-        <p:nvSpPr>
-          <p:cNvPr id="26" name="TextBox 25"/>
           <p:cNvSpPr txBox="1"/>
           <p:nvPr/>
         </p:nvSpPr>
@@ -11232,7 +11035,7 @@
       </p:sp>
       <p:sp>
         <p:nvSpPr>
-          <p:cNvPr id="27" name="TextBox 26"/>
+          <p:cNvPr id="9" name="TextBox 8"/>
           <p:cNvSpPr txBox="1"/>
           <p:nvPr/>
         </p:nvSpPr>
@@ -11354,7 +11157,7 @@
                 </a:solidFill>
                 <a:latin typeface="Calibri"/>
               </a:rPr>
-              <a:t>27. Implicações de Política</a:t>
+              <a:t>21. Síntese — Triângulo de Evidências</a:t>
             </a:r>
           </a:p>
         </p:txBody>
@@ -11389,7 +11192,7 @@
                 </a:solidFill>
                 <a:latin typeface="Calibri"/>
               </a:rPr>
-              <a:t>Três eixos simultâneos — ações isoladas são insuficientes para romper a armadilha estrutural</a:t>
+              <a:t>Os métodos do núcleo apontam para o mesmo diagnóstico</a:t>
             </a:r>
           </a:p>
         </p:txBody>
@@ -11402,8 +11205,8 @@
         </p:nvSpPr>
         <p:spPr>
           <a:xfrm>
-            <a:off x="274320" y="1097280"/>
-            <a:ext cx="3749039" cy="5029200"/>
+            <a:off x="274320" y="1188720"/>
+            <a:ext cx="5303520" cy="2377440"/>
           </a:xfrm>
           <a:prstGeom prst="rect">
             <a:avLst/>
@@ -11447,8 +11250,8 @@
         </p:nvSpPr>
         <p:spPr>
           <a:xfrm>
-            <a:off x="274320" y="1097280"/>
-            <a:ext cx="3749039" cy="502920"/>
+            <a:off x="274320" y="1188720"/>
+            <a:ext cx="5303520" cy="457200"/>
           </a:xfrm>
           <a:prstGeom prst="rect">
             <a:avLst/>
@@ -11488,8 +11291,44 @@
         </p:nvSpPr>
         <p:spPr>
           <a:xfrm>
-            <a:off x="365760" y="1143000"/>
-            <a:ext cx="3566160" cy="457200"/>
+            <a:off x="365760" y="1234440"/>
+            <a:ext cx="5120640" cy="411480"/>
+          </a:xfrm>
+          <a:prstGeom prst="rect">
+            <a:avLst/>
+          </a:prstGeom>
+          <a:noFill/>
+        </p:spPr>
+        <p:txBody>
+          <a:bodyPr wrap="square">
+            <a:spAutoFit/>
+          </a:bodyPr>
+          <a:lstStyle/>
+          <a:p>
+            <a:pPr algn="ctr"/>
+            <a:r>
+              <a:rPr sz="1300" b="1" i="0">
+                <a:solidFill>
+                  <a:srgbClr val="FFFFFF"/>
+                </a:solidFill>
+                <a:latin typeface="Calibri"/>
+              </a:rPr>
+              <a:t>DISCRIMINAÇÃO
+DE ACESSO</a:t>
+            </a:r>
+          </a:p>
+        </p:txBody>
+      </p:sp>
+      <p:sp>
+        <p:nvSpPr>
+          <p:cNvPr id="8" name="TextBox 7"/>
+          <p:cNvSpPr txBox="1"/>
+          <p:nvPr/>
+        </p:nvSpPr>
+        <p:spPr>
+          <a:xfrm>
+            <a:off x="457200" y="1737360"/>
+            <a:ext cx="4937760" cy="502920"/>
           </a:xfrm>
           <a:prstGeom prst="rect">
             <a:avLst/>
@@ -11504,27 +11343,27 @@
           <a:p>
             <a:pPr algn="l"/>
             <a:r>
-              <a:rPr sz="1300" b="1" i="0">
-                <a:solidFill>
-                  <a:srgbClr val="FFFFFF"/>
-                </a:solidFill>
-                <a:latin typeface="Calibri"/>
-              </a:rPr>
-              <a:t>Eixo 1 — Acesso</a:t>
-            </a:r>
-          </a:p>
-        </p:txBody>
-      </p:sp>
-      <p:sp>
-        <p:nvSpPr>
-          <p:cNvPr id="8" name="TextBox 7"/>
-          <p:cNvSpPr txBox="1"/>
-          <p:nvPr/>
-        </p:nvSpPr>
-        <p:spPr>
-          <a:xfrm>
-            <a:off x="457200" y="1691640"/>
-            <a:ext cx="3383280" cy="731520"/>
+              <a:rPr sz="1200" b="0" i="0">
+                <a:solidFill>
+                  <a:srgbClr val="212121"/>
+                </a:solidFill>
+                <a:latin typeface="Calibri"/>
+              </a:rPr>
+              <a:t>• GLMM: OR=0,693 para ocp. qualificada</a:t>
+            </a:r>
+          </a:p>
+        </p:txBody>
+      </p:sp>
+      <p:sp>
+        <p:nvSpPr>
+          <p:cNvPr id="9" name="TextBox 8"/>
+          <p:cNvSpPr txBox="1"/>
+          <p:nvPr/>
+        </p:nvSpPr>
+        <p:spPr>
+          <a:xfrm>
+            <a:off x="457200" y="2286000"/>
+            <a:ext cx="4937760" cy="502920"/>
           </a:xfrm>
           <a:prstGeom prst="rect">
             <a:avLst/>
@@ -11545,22 +11384,21 @@
                 </a:solidFill>
                 <a:latin typeface="Calibri"/>
               </a:rPr>
-              <a:t>▸  Cotas de acesso CBO Dirigente/Profissional:
-meta IR ≥ 0,80 até 2030</a:t>
-            </a:r>
-          </a:p>
-        </p:txBody>
-      </p:sp>
-      <p:sp>
-        <p:nvSpPr>
-          <p:cNvPr id="9" name="TextBox 8"/>
-          <p:cNvSpPr txBox="1"/>
-          <p:nvPr/>
-        </p:nvSpPr>
-        <p:spPr>
-          <a:xfrm>
-            <a:off x="457200" y="2468880"/>
-            <a:ext cx="3383280" cy="731520"/>
+              <a:t>• AME=−4,73 p.p. residual (M2)</a:t>
+            </a:r>
+          </a:p>
+        </p:txBody>
+      </p:sp>
+      <p:sp>
+        <p:nvSpPr>
+          <p:cNvPr id="10" name="TextBox 9"/>
+          <p:cNvSpPr txBox="1"/>
+          <p:nvPr/>
+        </p:nvSpPr>
+        <p:spPr>
+          <a:xfrm>
+            <a:off x="457200" y="2834640"/>
+            <a:ext cx="4937760" cy="502920"/>
           </a:xfrm>
           <a:prstGeom prst="rect">
             <a:avLst/>
@@ -11581,44 +11419,7 @@
                 </a:solidFill>
                 <a:latin typeface="Calibri"/>
               </a:rPr>
-              <a:t>▸  PRONATEC c/ recorte racial e subsídio de
-transporte para trabalhadores de UPAs pobres</a:t>
-            </a:r>
-          </a:p>
-        </p:txBody>
-      </p:sp>
-      <p:sp>
-        <p:nvSpPr>
-          <p:cNvPr id="10" name="TextBox 9"/>
-          <p:cNvSpPr txBox="1"/>
-          <p:nvPr/>
-        </p:nvSpPr>
-        <p:spPr>
-          <a:xfrm>
-            <a:off x="457200" y="3246120"/>
-            <a:ext cx="3383280" cy="731520"/>
-          </a:xfrm>
-          <a:prstGeom prst="rect">
-            <a:avLst/>
-          </a:prstGeom>
-          <a:noFill/>
-        </p:spPr>
-        <p:txBody>
-          <a:bodyPr wrap="square">
-            <a:spAutoFit/>
-          </a:bodyPr>
-          <a:lstStyle/>
-          <a:p>
-            <a:pPr algn="l"/>
-            <a:r>
-              <a:rPr sz="1200" b="0" i="0">
-                <a:solidFill>
-                  <a:srgbClr val="212121"/>
-                </a:solidFill>
-                <a:latin typeface="Calibri"/>
-              </a:rPr>
-              <a:t>▸  Bolsas de residência profissional em empresas
-de alta remuneração para egressos negros</a:t>
+              <a:t>• Persiste após todos os controles observáveis</a:t>
             </a:r>
           </a:p>
         </p:txBody>
@@ -11631,8 +11432,8 @@
         </p:nvSpPr>
         <p:spPr>
           <a:xfrm>
-            <a:off x="4251959" y="1097280"/>
-            <a:ext cx="3749039" cy="5029200"/>
+            <a:off x="6309360" y="1188720"/>
+            <a:ext cx="5303520" cy="2377440"/>
           </a:xfrm>
           <a:prstGeom prst="rect">
             <a:avLst/>
@@ -11676,8 +11477,8 @@
         </p:nvSpPr>
         <p:spPr>
           <a:xfrm>
-            <a:off x="4251959" y="1097280"/>
-            <a:ext cx="3749039" cy="502920"/>
+            <a:off x="6309360" y="1188720"/>
+            <a:ext cx="5303520" cy="457200"/>
           </a:xfrm>
           <a:prstGeom prst="rect">
             <a:avLst/>
@@ -11717,8 +11518,44 @@
         </p:nvSpPr>
         <p:spPr>
           <a:xfrm>
-            <a:off x="4343399" y="1143000"/>
-            <a:ext cx="3566160" cy="457200"/>
+            <a:off x="6400800" y="1234440"/>
+            <a:ext cx="5120640" cy="411480"/>
+          </a:xfrm>
+          <a:prstGeom prst="rect">
+            <a:avLst/>
+          </a:prstGeom>
+          <a:noFill/>
+        </p:spPr>
+        <p:txBody>
+          <a:bodyPr wrap="square">
+            <a:spAutoFit/>
+          </a:bodyPr>
+          <a:lstStyle/>
+          <a:p>
+            <a:pPr algn="ctr"/>
+            <a:r>
+              <a:rPr sz="1300" b="1" i="0">
+                <a:solidFill>
+                  <a:srgbClr val="FFFFFF"/>
+                </a:solidFill>
+                <a:latin typeface="Calibri"/>
+              </a:rPr>
+              <a:t>DISCRIMINAÇÃO
+DE REMUNERAÇÃO</a:t>
+            </a:r>
+          </a:p>
+        </p:txBody>
+      </p:sp>
+      <p:sp>
+        <p:nvSpPr>
+          <p:cNvPr id="14" name="TextBox 13"/>
+          <p:cNvSpPr txBox="1"/>
+          <p:nvPr/>
+        </p:nvSpPr>
+        <p:spPr>
+          <a:xfrm>
+            <a:off x="6492240" y="1737360"/>
+            <a:ext cx="4937760" cy="502920"/>
           </a:xfrm>
           <a:prstGeom prst="rect">
             <a:avLst/>
@@ -11733,27 +11570,27 @@
           <a:p>
             <a:pPr algn="l"/>
             <a:r>
-              <a:rPr sz="1300" b="1" i="0">
-                <a:solidFill>
-                  <a:srgbClr val="FFFFFF"/>
-                </a:solidFill>
-                <a:latin typeface="Calibri"/>
-              </a:rPr>
-              <a:t>Eixo 2 — Remuneração</a:t>
-            </a:r>
-          </a:p>
-        </p:txBody>
-      </p:sp>
-      <p:sp>
-        <p:nvSpPr>
-          <p:cNvPr id="14" name="TextBox 13"/>
-          <p:cNvSpPr txBox="1"/>
-          <p:nvPr/>
-        </p:nvSpPr>
-        <p:spPr>
-          <a:xfrm>
-            <a:off x="4434839" y="1691640"/>
-            <a:ext cx="3383280" cy="731520"/>
+              <a:rPr sz="1200" b="0" i="0">
+                <a:solidFill>
+                  <a:srgbClr val="212121"/>
+                </a:solidFill>
+                <a:latin typeface="Calibri"/>
+              </a:rPr>
+              <a:t>• HLM M4: gap residual 6,2%</a:t>
+            </a:r>
+          </a:p>
+        </p:txBody>
+      </p:sp>
+      <p:sp>
+        <p:nvSpPr>
+          <p:cNvPr id="15" name="TextBox 14"/>
+          <p:cNvSpPr txBox="1"/>
+          <p:nvPr/>
+        </p:nvSpPr>
+        <p:spPr>
+          <a:xfrm>
+            <a:off x="6492240" y="2286000"/>
+            <a:ext cx="4937760" cy="502920"/>
           </a:xfrm>
           <a:prstGeom prst="rect">
             <a:avLst/>
@@ -11774,22 +11611,21 @@
                 </a:solidFill>
                 <a:latin typeface="Calibri"/>
               </a:rPr>
-              <a:t>▸  Transparência salarial por raça/gênero
-obrigatória (empresas &gt; 100 funcionários)</a:t>
-            </a:r>
-          </a:p>
-        </p:txBody>
-      </p:sp>
-      <p:sp>
-        <p:nvSpPr>
-          <p:cNvPr id="15" name="TextBox 14"/>
-          <p:cNvSpPr txBox="1"/>
-          <p:nvPr/>
-        </p:nvSpPr>
-        <p:spPr>
-          <a:xfrm>
-            <a:off x="4434839" y="2468880"/>
-            <a:ext cx="3383280" cy="731520"/>
+              <a:t>• Quantile Reg.: cresce no topo (glass ceiling)</a:t>
+            </a:r>
+          </a:p>
+        </p:txBody>
+      </p:sp>
+      <p:sp>
+        <p:nvSpPr>
+          <p:cNvPr id="16" name="TextBox 15"/>
+          <p:cNvSpPr txBox="1"/>
+          <p:nvPr/>
+        </p:nvSpPr>
+        <p:spPr>
+          <a:xfrm>
+            <a:off x="6492240" y="2834640"/>
+            <a:ext cx="4937760" cy="502920"/>
           </a:xfrm>
           <a:prstGeom prst="rect">
             <a:avLst/>
@@ -11810,44 +11646,7 @@
                 </a:solidFill>
                 <a:latin typeface="Calibri"/>
               </a:rPr>
-              <a:t>▸  Auditoria de igual pagamento por trabalho igual
-com penalidades progressivas (gap HLM M4)</a:t>
-            </a:r>
-          </a:p>
-        </p:txBody>
-      </p:sp>
-      <p:sp>
-        <p:nvSpPr>
-          <p:cNvPr id="16" name="TextBox 15"/>
-          <p:cNvSpPr txBox="1"/>
-          <p:nvPr/>
-        </p:nvSpPr>
-        <p:spPr>
-          <a:xfrm>
-            <a:off x="4434839" y="3246120"/>
-            <a:ext cx="3383280" cy="731520"/>
-          </a:xfrm>
-          <a:prstGeom prst="rect">
-            <a:avLst/>
-          </a:prstGeom>
-          <a:noFill/>
-        </p:spPr>
-        <p:txBody>
-          <a:bodyPr wrap="square">
-            <a:spAutoFit/>
-          </a:bodyPr>
-          <a:lstStyle/>
-          <a:p>
-            <a:pPr algn="l"/>
-            <a:r>
-              <a:rPr sz="1200" b="0" i="0">
-                <a:solidFill>
-                  <a:srgbClr val="212121"/>
-                </a:solidFill>
-                <a:latin typeface="Calibri"/>
-              </a:rPr>
-              <a:t>▸  Piso salarial indexado nas categorias com
-maior gap racial residual (6,2% HLM M4)</a:t>
+              <a:t>• SHAP: −2,5% efeito racial residual</a:t>
             </a:r>
           </a:p>
         </p:txBody>
@@ -11860,8 +11659,8 @@
         </p:nvSpPr>
         <p:spPr>
           <a:xfrm>
-            <a:off x="8229598" y="1097280"/>
-            <a:ext cx="3749039" cy="5029200"/>
+            <a:off x="3291840" y="3931920"/>
+            <a:ext cx="5303520" cy="2377440"/>
           </a:xfrm>
           <a:prstGeom prst="rect">
             <a:avLst/>
@@ -11871,7 +11670,7 @@
           </a:solidFill>
           <a:ln w="19050">
             <a:solidFill>
-              <a:srgbClr val="2E7D32"/>
+              <a:srgbClr val="1F3864"/>
             </a:solidFill>
           </a:ln>
         </p:spPr>
@@ -11905,14 +11704,14 @@
         </p:nvSpPr>
         <p:spPr>
           <a:xfrm>
-            <a:off x="8229598" y="1097280"/>
-            <a:ext cx="3749039" cy="502920"/>
+            <a:off x="3291840" y="3931920"/>
+            <a:ext cx="5303520" cy="457200"/>
           </a:xfrm>
           <a:prstGeom prst="rect">
             <a:avLst/>
           </a:prstGeom>
           <a:solidFill>
-            <a:srgbClr val="2E7D32"/>
+            <a:srgbClr val="1F3864"/>
           </a:solidFill>
           <a:ln/>
         </p:spPr>
@@ -11946,8 +11745,44 @@
         </p:nvSpPr>
         <p:spPr>
           <a:xfrm>
-            <a:off x="8321038" y="1143000"/>
-            <a:ext cx="3566160" cy="457200"/>
+            <a:off x="3383280" y="3977640"/>
+            <a:ext cx="5120640" cy="411480"/>
+          </a:xfrm>
+          <a:prstGeom prst="rect">
+            <a:avLst/>
+          </a:prstGeom>
+          <a:noFill/>
+        </p:spPr>
+        <p:txBody>
+          <a:bodyPr wrap="square">
+            <a:spAutoFit/>
+          </a:bodyPr>
+          <a:lstStyle/>
+          <a:p>
+            <a:pPr algn="ctr"/>
+            <a:r>
+              <a:rPr sz="1300" b="1" i="0">
+                <a:solidFill>
+                  <a:srgbClr val="FFFFFF"/>
+                </a:solidFill>
+                <a:latin typeface="Calibri"/>
+              </a:rPr>
+              <a:t>PENALIDADE
+INTERSECCIONAL</a:t>
+            </a:r>
+          </a:p>
+        </p:txBody>
+      </p:sp>
+      <p:sp>
+        <p:nvSpPr>
+          <p:cNvPr id="20" name="TextBox 19"/>
+          <p:cNvSpPr txBox="1"/>
+          <p:nvPr/>
+        </p:nvSpPr>
+        <p:spPr>
+          <a:xfrm>
+            <a:off x="3474720" y="4480560"/>
+            <a:ext cx="4937760" cy="502920"/>
           </a:xfrm>
           <a:prstGeom prst="rect">
             <a:avLst/>
@@ -11962,27 +11797,27 @@
           <a:p>
             <a:pPr algn="l"/>
             <a:r>
-              <a:rPr sz="1300" b="1" i="0">
-                <a:solidFill>
-                  <a:srgbClr val="FFFFFF"/>
-                </a:solidFill>
-                <a:latin typeface="Calibri"/>
-              </a:rPr>
-              <a:t>Eixo 3 — Acesso a Ocupações</a:t>
-            </a:r>
-          </a:p>
-        </p:txBody>
-      </p:sp>
-      <p:sp>
-        <p:nvSpPr>
-          <p:cNvPr id="20" name="TextBox 19"/>
-          <p:cNvSpPr txBox="1"/>
-          <p:nvPr/>
-        </p:nvSpPr>
-        <p:spPr>
-          <a:xfrm>
-            <a:off x="8412478" y="1691640"/>
-            <a:ext cx="3383280" cy="731520"/>
+              <a:rPr sz="1200" b="0" i="0">
+                <a:solidFill>
+                  <a:srgbClr val="212121"/>
+                </a:solidFill>
+                <a:latin typeface="Calibri"/>
+              </a:rPr>
+              <a:t>• Mulher Negra: gap de 96,4%</a:t>
+            </a:r>
+          </a:p>
+        </p:txBody>
+      </p:sp>
+      <p:sp>
+        <p:nvSpPr>
+          <p:cNvPr id="21" name="TextBox 20"/>
+          <p:cNvSpPr txBox="1"/>
+          <p:nvPr/>
+        </p:nvSpPr>
+        <p:spPr>
+          <a:xfrm>
+            <a:off x="3474720" y="5029200"/>
+            <a:ext cx="4937760" cy="502920"/>
           </a:xfrm>
           <a:prstGeom prst="rect">
             <a:avLst/>
@@ -12003,22 +11838,21 @@
                 </a:solidFill>
                 <a:latin typeface="Calibri"/>
               </a:rPr>
-              <a:t>▸  Mentoria e acesso a redes profissionais
-qualificadas para egressos negros</a:t>
-            </a:r>
-          </a:p>
-        </p:txBody>
-      </p:sp>
-      <p:sp>
-        <p:nvSpPr>
-          <p:cNvPr id="21" name="TextBox 20"/>
-          <p:cNvSpPr txBox="1"/>
-          <p:nvPr/>
-        </p:nvSpPr>
-        <p:spPr>
-          <a:xfrm>
-            <a:off x="8412478" y="2468880"/>
-            <a:ext cx="3383280" cy="731520"/>
+              <a:t>• Penalidade extra de +9,5 p.p. (não-aditiva)</a:t>
+            </a:r>
+          </a:p>
+        </p:txBody>
+      </p:sp>
+      <p:sp>
+        <p:nvSpPr>
+          <p:cNvPr id="22" name="TextBox 21"/>
+          <p:cNvSpPr txBox="1"/>
+          <p:nvPr/>
+        </p:nvSpPr>
+        <p:spPr>
+          <a:xfrm>
+            <a:off x="3474720" y="5577840"/>
+            <a:ext cx="4937760" cy="502920"/>
           </a:xfrm>
           <a:prstGeom prst="rect">
             <a:avLst/>
@@ -12039,93 +11873,21 @@
                 </a:solidFill>
                 <a:latin typeface="Calibri"/>
               </a:rPr>
-              <a:t>▸  30% dos cargos DAS e liderança corporativa
-para negros até 2030</a:t>
-            </a:r>
-          </a:p>
-        </p:txBody>
-      </p:sp>
-      <p:sp>
-        <p:nvSpPr>
-          <p:cNvPr id="22" name="TextBox 21"/>
-          <p:cNvSpPr txBox="1"/>
-          <p:nvPr/>
-        </p:nvSpPr>
-        <p:spPr>
-          <a:xfrm>
-            <a:off x="8412478" y="3246120"/>
-            <a:ext cx="3383280" cy="731520"/>
-          </a:xfrm>
-          <a:prstGeom prst="rect">
-            <a:avLst/>
-          </a:prstGeom>
-          <a:noFill/>
-        </p:spPr>
-        <p:txBody>
-          <a:bodyPr wrap="square">
-            <a:spAutoFit/>
-          </a:bodyPr>
-          <a:lstStyle/>
-          <a:p>
-            <a:pPr algn="l"/>
-            <a:r>
-              <a:rPr sz="1200" b="0" i="0">
-                <a:solidFill>
-                  <a:srgbClr val="212121"/>
-                </a:solidFill>
-                <a:latin typeface="Calibri"/>
-              </a:rPr>
-              <a:t>▸  Ampliar acesso a ocupações qualificadas:
-principal canal do gap (Oaxaca + GLMM)</a:t>
-            </a:r>
-          </a:p>
-        </p:txBody>
-      </p:sp>
-      <p:sp>
-        <p:nvSpPr>
-          <p:cNvPr id="23" name="TextBox 22"/>
-          <p:cNvSpPr txBox="1"/>
-          <p:nvPr/>
-        </p:nvSpPr>
-        <p:spPr>
-          <a:xfrm>
-            <a:off x="274320" y="6217920"/>
-            <a:ext cx="11612880" cy="411480"/>
-          </a:xfrm>
-          <a:prstGeom prst="rect">
-            <a:avLst/>
-          </a:prstGeom>
-          <a:noFill/>
-        </p:spPr>
-        <p:txBody>
-          <a:bodyPr wrap="square">
-            <a:spAutoFit/>
-          </a:bodyPr>
-          <a:lstStyle/>
-          <a:p>
-            <a:pPr algn="ctr"/>
-            <a:r>
-              <a:rPr sz="1300" b="1" i="0">
-                <a:solidFill>
-                  <a:srgbClr val="B71C1C"/>
-                </a:solidFill>
-                <a:latin typeface="Calibri"/>
-              </a:rPr>
-              <a:t>⚠  Ao ritmo atual de convergência (~0,02 log-pontos/ano), eliminar o gap levaria mais de 100 anos.</a:t>
-            </a:r>
-          </a:p>
-        </p:txBody>
-      </p:sp>
-      <p:sp>
-        <p:nvSpPr>
-          <p:cNvPr id="24" name="Rectangle 23"/>
+              <a:t>• Raça×gênero como mecanismo próprio (Crenshaw)</a:t>
+            </a:r>
+          </a:p>
+        </p:txBody>
+      </p:sp>
+      <p:sp>
+        <p:nvSpPr>
+          <p:cNvPr id="23" name="Rectangle 22"/>
           <p:cNvSpPr/>
           <p:nvPr/>
         </p:nvSpPr>
         <p:spPr>
           <a:xfrm>
-            <a:off x="0" y="6601968"/>
-            <a:ext cx="12188952" cy="256032"/>
+            <a:off x="274320" y="5852160"/>
+            <a:ext cx="11612880" cy="457200"/>
           </a:xfrm>
           <a:prstGeom prst="rect">
             <a:avLst/>
@@ -12159,7 +11921,83 @@
       </p:sp>
       <p:sp>
         <p:nvSpPr>
-          <p:cNvPr id="25" name="TextBox 24"/>
+          <p:cNvPr id="24" name="TextBox 23"/>
+          <p:cNvSpPr txBox="1"/>
+          <p:nvPr/>
+        </p:nvSpPr>
+        <p:spPr>
+          <a:xfrm>
+            <a:off x="457200" y="5897880"/>
+            <a:ext cx="11247120" cy="411480"/>
+          </a:xfrm>
+          <a:prstGeom prst="rect">
+            <a:avLst/>
+          </a:prstGeom>
+          <a:noFill/>
+        </p:spPr>
+        <p:txBody>
+          <a:bodyPr wrap="square">
+            <a:spAutoFit/>
+          </a:bodyPr>
+          <a:lstStyle/>
+          <a:p>
+            <a:pPr algn="ctr"/>
+            <a:r>
+              <a:rPr sz="1200" b="1" i="0">
+                <a:solidFill>
+                  <a:srgbClr val="FFFFFF"/>
+                </a:solidFill>
+                <a:latin typeface="Calibri"/>
+              </a:rPr>
+              <a:t>Oaxaca: 83,8% do gap é composição/ACESSO e 16,2% remuneração | GLMM mostra a barreira de acesso (OR=0,705) | RIF: discriminação de preço maior na base (sticky floor)</a:t>
+            </a:r>
+          </a:p>
+        </p:txBody>
+      </p:sp>
+      <p:sp>
+        <p:nvSpPr>
+          <p:cNvPr id="25" name="Rectangle 24"/>
+          <p:cNvSpPr/>
+          <p:nvPr/>
+        </p:nvSpPr>
+        <p:spPr>
+          <a:xfrm>
+            <a:off x="0" y="6601968"/>
+            <a:ext cx="12188952" cy="256032"/>
+          </a:xfrm>
+          <a:prstGeom prst="rect">
+            <a:avLst/>
+          </a:prstGeom>
+          <a:solidFill>
+            <a:srgbClr val="1F3864"/>
+          </a:solidFill>
+          <a:ln/>
+        </p:spPr>
+        <p:style>
+          <a:lnRef idx="1">
+            <a:schemeClr val="accent1"/>
+          </a:lnRef>
+          <a:fillRef idx="3">
+            <a:schemeClr val="accent1"/>
+          </a:fillRef>
+          <a:effectRef idx="2">
+            <a:schemeClr val="accent1"/>
+          </a:effectRef>
+          <a:fontRef idx="minor">
+            <a:schemeClr val="lt1"/>
+          </a:fontRef>
+        </p:style>
+        <p:txBody>
+          <a:bodyPr rtlCol="0" anchor="ctr"/>
+          <a:lstStyle/>
+          <a:p>
+            <a:pPr algn="ctr"/>
+          </a:p>
+        </p:txBody>
+      </p:sp>
+      <p:sp>
+        <p:nvSpPr>
+          <p:cNvPr id="26" name="TextBox 25"/>
           <p:cNvSpPr txBox="1"/>
           <p:nvPr/>
         </p:nvSpPr>
@@ -12194,7 +12032,7 @@
       </p:sp>
       <p:sp>
         <p:nvSpPr>
-          <p:cNvPr id="26" name="TextBox 25"/>
+          <p:cNvPr id="27" name="TextBox 26"/>
           <p:cNvSpPr txBox="1"/>
           <p:nvPr/>
         </p:nvSpPr>
@@ -12222,7 +12060,7 @@
                 </a:solidFill>
                 <a:latin typeface="Calibri"/>
               </a:rPr>
-              <a:t>28/29</a:t>
+              <a:t>22/29</a:t>
             </a:r>
           </a:p>
         </p:txBody>
@@ -12316,7 +12154,7 @@
                 </a:solidFill>
                 <a:latin typeface="Calibri"/>
               </a:rPr>
-              <a:t>28. Limitações e Agenda Futura</a:t>
+              <a:t>27. Implicações de Política</a:t>
             </a:r>
           </a:p>
         </p:txBody>
@@ -12351,370 +12189,33 @@
                 </a:solidFill>
                 <a:latin typeface="Calibri"/>
               </a:rPr>
-              <a:t>Honestidade acadêmica: o que este trabalho não faz e por quê</a:t>
-            </a:r>
-          </a:p>
-        </p:txBody>
-      </p:sp>
-      <p:sp>
-        <p:nvSpPr>
-          <p:cNvPr id="5" name="TextBox 4"/>
-          <p:cNvSpPr txBox="1"/>
-          <p:nvPr/>
-        </p:nvSpPr>
-        <p:spPr>
-          <a:xfrm>
-            <a:off x="365760" y="1143000"/>
-            <a:ext cx="5486400" cy="365760"/>
-          </a:xfrm>
-          <a:prstGeom prst="rect">
-            <a:avLst/>
-          </a:prstGeom>
-          <a:noFill/>
-        </p:spPr>
-        <p:txBody>
-          <a:bodyPr wrap="square">
-            <a:spAutoFit/>
-          </a:bodyPr>
-          <a:lstStyle/>
-          <a:p>
-            <a:pPr algn="l"/>
-            <a:r>
-              <a:rPr sz="1600" b="1" i="0">
-                <a:solidFill>
-                  <a:srgbClr val="B71C1C"/>
-                </a:solidFill>
-                <a:latin typeface="Calibri"/>
-              </a:rPr>
-              <a:t>Limitações</a:t>
-            </a:r>
-          </a:p>
-        </p:txBody>
-      </p:sp>
-      <p:sp>
-        <p:nvSpPr>
-          <p:cNvPr id="6" name="TextBox 5"/>
-          <p:cNvSpPr txBox="1"/>
-          <p:nvPr/>
-        </p:nvSpPr>
-        <p:spPr>
-          <a:xfrm>
-            <a:off x="365760" y="1600200"/>
-            <a:ext cx="5669280" cy="3474720"/>
-          </a:xfrm>
-          <a:prstGeom prst="rect">
-            <a:avLst/>
-          </a:prstGeom>
-          <a:noFill/>
-        </p:spPr>
-        <p:txBody>
-          <a:bodyPr wrap="square">
-            <a:spAutoFit/>
-          </a:bodyPr>
-          <a:lstStyle/>
-          <a:p>
-            <a:pPr>
-              <a:spcAft>
-                <a:spcPts val="400"/>
-              </a:spcAft>
-            </a:pPr>
-            <a:r>
-              <a:rPr sz="1300" b="1">
-                <a:solidFill>
-                  <a:srgbClr val="B71C1C"/>
-                </a:solidFill>
-                <a:latin typeface="Calibri"/>
-              </a:rPr>
-              <a:t>▸  </a:t>
-            </a:r>
-            <a:r>
-              <a:rPr sz="1300">
-                <a:solidFill>
-                  <a:srgbClr val="212121"/>
-                </a:solidFill>
-                <a:latin typeface="Calibri"/>
-              </a:rPr>
-              <a:t>PNAD não permite experimentos causais — coeficientes são associações condicionais, não efeitos causais no sentido de Rubin/Pearl</a:t>
-            </a:r>
-          </a:p>
-          <a:p>
-            <a:pPr>
-              <a:spcAft>
-                <a:spcPts val="400"/>
-              </a:spcAft>
-            </a:pPr>
-            <a:r>
-              <a:rPr sz="1300" b="1">
-                <a:solidFill>
-                  <a:srgbClr val="B71C1C"/>
-                </a:solidFill>
-                <a:latin typeface="Calibri"/>
-              </a:rPr>
-              <a:t>▸  </a:t>
-            </a:r>
-            <a:r>
-              <a:rPr sz="1300">
-                <a:solidFill>
-                  <a:srgbClr val="212121"/>
-                </a:solidFill>
-                <a:latin typeface="Calibri"/>
-              </a:rPr>
-              <a:t>UPA como proxy de bairro: unidade de amostragem ≠ bairro administrativo</a:t>
-            </a:r>
-          </a:p>
-          <a:p>
-            <a:pPr>
-              <a:spcAft>
-                <a:spcPts val="400"/>
-              </a:spcAft>
-            </a:pPr>
-            <a:r>
-              <a:rPr sz="1300" b="1">
-                <a:solidFill>
-                  <a:srgbClr val="B71C1C"/>
-                </a:solidFill>
-                <a:latin typeface="Calibri"/>
-              </a:rPr>
-              <a:t>▸  </a:t>
-            </a:r>
-            <a:r>
-              <a:rPr sz="1300">
-                <a:solidFill>
-                  <a:srgbClr val="212121"/>
-                </a:solidFill>
-                <a:latin typeface="Calibri"/>
-              </a:rPr>
-              <a:t>GLMM logístico estimado na PEA completa via lme4::glmer (nAGQ=0, bobyqa, n=7,7M, 40,9k UPAs), com efeito aleatório de UPA</a:t>
-            </a:r>
-          </a:p>
-          <a:p>
-            <a:pPr>
-              <a:spcAft>
-                <a:spcPts val="400"/>
-              </a:spcAft>
-            </a:pPr>
-            <a:r>
-              <a:rPr sz="1300" b="1">
-                <a:solidFill>
-                  <a:srgbClr val="B71C1C"/>
-                </a:solidFill>
-                <a:latin typeface="Calibri"/>
-              </a:rPr>
-              <a:t>▸  </a:t>
-            </a:r>
-            <a:r>
-              <a:rPr sz="1300">
-                <a:solidFill>
-                  <a:srgbClr val="212121"/>
-                </a:solidFill>
-                <a:latin typeface="Calibri"/>
-              </a:rPr>
-              <a:t>CBO auto-declarado pode ter viés de classificação por raça (deflation de ocupação)</a:t>
-            </a:r>
-          </a:p>
-        </p:txBody>
-      </p:sp>
-      <p:sp>
-        <p:nvSpPr>
-          <p:cNvPr id="7" name="TextBox 6"/>
-          <p:cNvSpPr txBox="1"/>
-          <p:nvPr/>
-        </p:nvSpPr>
-        <p:spPr>
-          <a:xfrm>
-            <a:off x="6400800" y="1143000"/>
-            <a:ext cx="5486400" cy="365760"/>
-          </a:xfrm>
-          <a:prstGeom prst="rect">
-            <a:avLst/>
-          </a:prstGeom>
-          <a:noFill/>
-        </p:spPr>
-        <p:txBody>
-          <a:bodyPr wrap="square">
-            <a:spAutoFit/>
-          </a:bodyPr>
-          <a:lstStyle/>
-          <a:p>
-            <a:pPr algn="l"/>
-            <a:r>
-              <a:rPr sz="1600" b="1" i="0">
-                <a:solidFill>
-                  <a:srgbClr val="1565C0"/>
-                </a:solidFill>
-                <a:latin typeface="Calibri"/>
-              </a:rPr>
-              <a:t>Agenda Futura</a:t>
-            </a:r>
-          </a:p>
-        </p:txBody>
-      </p:sp>
-      <p:sp>
-        <p:nvSpPr>
-          <p:cNvPr id="8" name="TextBox 7"/>
-          <p:cNvSpPr txBox="1"/>
-          <p:nvPr/>
-        </p:nvSpPr>
-        <p:spPr>
-          <a:xfrm>
-            <a:off x="6400800" y="1600200"/>
-            <a:ext cx="5669280" cy="3474720"/>
-          </a:xfrm>
-          <a:prstGeom prst="rect">
-            <a:avLst/>
-          </a:prstGeom>
-          <a:noFill/>
-        </p:spPr>
-        <p:txBody>
-          <a:bodyPr wrap="square">
-            <a:spAutoFit/>
-          </a:bodyPr>
-          <a:lstStyle/>
-          <a:p>
-            <a:pPr>
-              <a:spcAft>
-                <a:spcPts val="400"/>
-              </a:spcAft>
-            </a:pPr>
-            <a:r>
-              <a:rPr sz="1300" b="1">
-                <a:solidFill>
-                  <a:srgbClr val="1565C0"/>
-                </a:solidFill>
-                <a:latin typeface="Calibri"/>
-              </a:rPr>
-              <a:t>▸  </a:t>
-            </a:r>
-            <a:r>
-              <a:rPr sz="1300">
-                <a:solidFill>
-                  <a:srgbClr val="212121"/>
-                </a:solidFill>
-                <a:latin typeface="Calibri"/>
-              </a:rPr>
-              <a:t>Análise de variáveis instrumentais (IV) para identificação causal — distância à escola técnica como instrumento</a:t>
-            </a:r>
-          </a:p>
-          <a:p>
-            <a:pPr>
-              <a:spcAft>
-                <a:spcPts val="400"/>
-              </a:spcAft>
-            </a:pPr>
-            <a:r>
-              <a:rPr sz="1300" b="1">
-                <a:solidFill>
-                  <a:srgbClr val="1565C0"/>
-                </a:solidFill>
-                <a:latin typeface="Calibri"/>
-              </a:rPr>
-              <a:t>▸  </a:t>
-            </a:r>
-            <a:r>
-              <a:rPr sz="1300">
-                <a:solidFill>
-                  <a:srgbClr val="212121"/>
-                </a:solidFill>
-                <a:latin typeface="Calibri"/>
-              </a:rPr>
-              <a:t>RAIS linkada à PNAD para rastrear trajetórias de mobilidade intraempresa</a:t>
-            </a:r>
-          </a:p>
-          <a:p>
-            <a:pPr>
-              <a:spcAft>
-                <a:spcPts val="400"/>
-              </a:spcAft>
-            </a:pPr>
-            <a:r>
-              <a:rPr sz="1300" b="1">
-                <a:solidFill>
-                  <a:srgbClr val="1565C0"/>
-                </a:solidFill>
-                <a:latin typeface="Calibri"/>
-              </a:rPr>
-              <a:t>▸  </a:t>
-            </a:r>
-            <a:r>
-              <a:rPr sz="1300">
-                <a:solidFill>
-                  <a:srgbClr val="212121"/>
-                </a:solidFill>
-                <a:latin typeface="Calibri"/>
-              </a:rPr>
-              <a:t>Análise de mediação formal (path analysis) raça → ocupação → renda</a:t>
-            </a:r>
-          </a:p>
-          <a:p>
-            <a:pPr>
-              <a:spcAft>
-                <a:spcPts val="400"/>
-              </a:spcAft>
-            </a:pPr>
-            <a:r>
-              <a:rPr sz="1300" b="1">
-                <a:solidFill>
-                  <a:srgbClr val="1565C0"/>
-                </a:solidFill>
-                <a:latin typeface="Calibri"/>
-              </a:rPr>
-              <a:t>▸  </a:t>
-            </a:r>
-            <a:r>
-              <a:rPr sz="1300">
-                <a:solidFill>
-                  <a:srgbClr val="212121"/>
-                </a:solidFill>
-                <a:latin typeface="Calibri"/>
-              </a:rPr>
-              <a:t>Extensão ao setor público por UF — heterogeneidade do glass ceiling entre estados</a:t>
-            </a:r>
-          </a:p>
-          <a:p>
-            <a:pPr>
-              <a:spcAft>
-                <a:spcPts val="400"/>
-              </a:spcAft>
-            </a:pPr>
-            <a:r>
-              <a:rPr sz="1300" b="1">
-                <a:solidFill>
-                  <a:srgbClr val="1565C0"/>
-                </a:solidFill>
-                <a:latin typeface="Calibri"/>
-              </a:rPr>
-              <a:t>▸  </a:t>
-            </a:r>
-            <a:r>
-              <a:rPr sz="1300">
-                <a:solidFill>
-                  <a:srgbClr val="212121"/>
-                </a:solidFill>
-                <a:latin typeface="Calibri"/>
-              </a:rPr>
-              <a:t>Modelo longitudinal com painéis rotativos da PNAD (2T seguidos) para efeitos fixos de indivíduo</a:t>
-            </a:r>
-          </a:p>
-        </p:txBody>
-      </p:sp>
-      <p:sp>
-        <p:nvSpPr>
-          <p:cNvPr id="9" name="Rectangle 8"/>
+              <a:t>Três eixos simultâneos — ações isoladas são insuficientes para romper a armadilha estrutural</a:t>
+            </a:r>
+          </a:p>
+        </p:txBody>
+      </p:sp>
+      <p:sp>
+        <p:nvSpPr>
+          <p:cNvPr id="5" name="Rectangle 4"/>
           <p:cNvSpPr/>
           <p:nvPr/>
         </p:nvSpPr>
         <p:spPr>
           <a:xfrm>
-            <a:off x="0" y="6601968"/>
-            <a:ext cx="12188952" cy="256032"/>
+            <a:off x="274320" y="1097280"/>
+            <a:ext cx="3749039" cy="5029200"/>
           </a:xfrm>
           <a:prstGeom prst="rect">
             <a:avLst/>
           </a:prstGeom>
           <a:solidFill>
-            <a:srgbClr val="1F3864"/>
+            <a:srgbClr val="F5F5F5"/>
           </a:solidFill>
-          <a:ln/>
+          <a:ln w="19050">
+            <a:solidFill>
+              <a:srgbClr val="B71C1C"/>
+            </a:solidFill>
+          </a:ln>
         </p:spPr>
         <p:style>
           <a:lnRef idx="1">
@@ -12740,7 +12241,725 @@
       </p:sp>
       <p:sp>
         <p:nvSpPr>
+          <p:cNvPr id="6" name="Rectangle 5"/>
+          <p:cNvSpPr/>
+          <p:nvPr/>
+        </p:nvSpPr>
+        <p:spPr>
+          <a:xfrm>
+            <a:off x="274320" y="1097280"/>
+            <a:ext cx="3749039" cy="502920"/>
+          </a:xfrm>
+          <a:prstGeom prst="rect">
+            <a:avLst/>
+          </a:prstGeom>
+          <a:solidFill>
+            <a:srgbClr val="B71C1C"/>
+          </a:solidFill>
+          <a:ln/>
+        </p:spPr>
+        <p:style>
+          <a:lnRef idx="1">
+            <a:schemeClr val="accent1"/>
+          </a:lnRef>
+          <a:fillRef idx="3">
+            <a:schemeClr val="accent1"/>
+          </a:fillRef>
+          <a:effectRef idx="2">
+            <a:schemeClr val="accent1"/>
+          </a:effectRef>
+          <a:fontRef idx="minor">
+            <a:schemeClr val="lt1"/>
+          </a:fontRef>
+        </p:style>
+        <p:txBody>
+          <a:bodyPr rtlCol="0" anchor="ctr"/>
+          <a:lstStyle/>
+          <a:p>
+            <a:pPr algn="ctr"/>
+          </a:p>
+        </p:txBody>
+      </p:sp>
+      <p:sp>
+        <p:nvSpPr>
+          <p:cNvPr id="7" name="TextBox 6"/>
+          <p:cNvSpPr txBox="1"/>
+          <p:nvPr/>
+        </p:nvSpPr>
+        <p:spPr>
+          <a:xfrm>
+            <a:off x="365760" y="1143000"/>
+            <a:ext cx="3566160" cy="457200"/>
+          </a:xfrm>
+          <a:prstGeom prst="rect">
+            <a:avLst/>
+          </a:prstGeom>
+          <a:noFill/>
+        </p:spPr>
+        <p:txBody>
+          <a:bodyPr wrap="square">
+            <a:spAutoFit/>
+          </a:bodyPr>
+          <a:lstStyle/>
+          <a:p>
+            <a:pPr algn="l"/>
+            <a:r>
+              <a:rPr sz="1300" b="1" i="0">
+                <a:solidFill>
+                  <a:srgbClr val="FFFFFF"/>
+                </a:solidFill>
+                <a:latin typeface="Calibri"/>
+              </a:rPr>
+              <a:t>Eixo 1 — Acesso</a:t>
+            </a:r>
+          </a:p>
+        </p:txBody>
+      </p:sp>
+      <p:sp>
+        <p:nvSpPr>
+          <p:cNvPr id="8" name="TextBox 7"/>
+          <p:cNvSpPr txBox="1"/>
+          <p:nvPr/>
+        </p:nvSpPr>
+        <p:spPr>
+          <a:xfrm>
+            <a:off x="457200" y="1691640"/>
+            <a:ext cx="3383280" cy="731520"/>
+          </a:xfrm>
+          <a:prstGeom prst="rect">
+            <a:avLst/>
+          </a:prstGeom>
+          <a:noFill/>
+        </p:spPr>
+        <p:txBody>
+          <a:bodyPr wrap="square">
+            <a:spAutoFit/>
+          </a:bodyPr>
+          <a:lstStyle/>
+          <a:p>
+            <a:pPr algn="l"/>
+            <a:r>
+              <a:rPr sz="1200" b="0" i="0">
+                <a:solidFill>
+                  <a:srgbClr val="212121"/>
+                </a:solidFill>
+                <a:latin typeface="Calibri"/>
+              </a:rPr>
+              <a:t>▸  Cotas de acesso CBO Dirigente/Profissional:
+meta IR ≥ 0,80 até 2030</a:t>
+            </a:r>
+          </a:p>
+        </p:txBody>
+      </p:sp>
+      <p:sp>
+        <p:nvSpPr>
+          <p:cNvPr id="9" name="TextBox 8"/>
+          <p:cNvSpPr txBox="1"/>
+          <p:nvPr/>
+        </p:nvSpPr>
+        <p:spPr>
+          <a:xfrm>
+            <a:off x="457200" y="2468880"/>
+            <a:ext cx="3383280" cy="731520"/>
+          </a:xfrm>
+          <a:prstGeom prst="rect">
+            <a:avLst/>
+          </a:prstGeom>
+          <a:noFill/>
+        </p:spPr>
+        <p:txBody>
+          <a:bodyPr wrap="square">
+            <a:spAutoFit/>
+          </a:bodyPr>
+          <a:lstStyle/>
+          <a:p>
+            <a:pPr algn="l"/>
+            <a:r>
+              <a:rPr sz="1200" b="0" i="0">
+                <a:solidFill>
+                  <a:srgbClr val="212121"/>
+                </a:solidFill>
+                <a:latin typeface="Calibri"/>
+              </a:rPr>
+              <a:t>▸  PRONATEC c/ recorte racial e subsídio de
+transporte para trabalhadores de UPAs pobres</a:t>
+            </a:r>
+          </a:p>
+        </p:txBody>
+      </p:sp>
+      <p:sp>
+        <p:nvSpPr>
           <p:cNvPr id="10" name="TextBox 9"/>
+          <p:cNvSpPr txBox="1"/>
+          <p:nvPr/>
+        </p:nvSpPr>
+        <p:spPr>
+          <a:xfrm>
+            <a:off x="457200" y="3246120"/>
+            <a:ext cx="3383280" cy="731520"/>
+          </a:xfrm>
+          <a:prstGeom prst="rect">
+            <a:avLst/>
+          </a:prstGeom>
+          <a:noFill/>
+        </p:spPr>
+        <p:txBody>
+          <a:bodyPr wrap="square">
+            <a:spAutoFit/>
+          </a:bodyPr>
+          <a:lstStyle/>
+          <a:p>
+            <a:pPr algn="l"/>
+            <a:r>
+              <a:rPr sz="1200" b="0" i="0">
+                <a:solidFill>
+                  <a:srgbClr val="212121"/>
+                </a:solidFill>
+                <a:latin typeface="Calibri"/>
+              </a:rPr>
+              <a:t>▸  Bolsas de residência profissional em empresas
+de alta remuneração para egressos negros</a:t>
+            </a:r>
+          </a:p>
+        </p:txBody>
+      </p:sp>
+      <p:sp>
+        <p:nvSpPr>
+          <p:cNvPr id="11" name="Rectangle 10"/>
+          <p:cNvSpPr/>
+          <p:nvPr/>
+        </p:nvSpPr>
+        <p:spPr>
+          <a:xfrm>
+            <a:off x="4251959" y="1097280"/>
+            <a:ext cx="3749039" cy="5029200"/>
+          </a:xfrm>
+          <a:prstGeom prst="rect">
+            <a:avLst/>
+          </a:prstGeom>
+          <a:solidFill>
+            <a:srgbClr val="F5F5F5"/>
+          </a:solidFill>
+          <a:ln w="19050">
+            <a:solidFill>
+              <a:srgbClr val="1565C0"/>
+            </a:solidFill>
+          </a:ln>
+        </p:spPr>
+        <p:style>
+          <a:lnRef idx="1">
+            <a:schemeClr val="accent1"/>
+          </a:lnRef>
+          <a:fillRef idx="3">
+            <a:schemeClr val="accent1"/>
+          </a:fillRef>
+          <a:effectRef idx="2">
+            <a:schemeClr val="accent1"/>
+          </a:effectRef>
+          <a:fontRef idx="minor">
+            <a:schemeClr val="lt1"/>
+          </a:fontRef>
+        </p:style>
+        <p:txBody>
+          <a:bodyPr rtlCol="0" anchor="ctr"/>
+          <a:lstStyle/>
+          <a:p>
+            <a:pPr algn="ctr"/>
+          </a:p>
+        </p:txBody>
+      </p:sp>
+      <p:sp>
+        <p:nvSpPr>
+          <p:cNvPr id="12" name="Rectangle 11"/>
+          <p:cNvSpPr/>
+          <p:nvPr/>
+        </p:nvSpPr>
+        <p:spPr>
+          <a:xfrm>
+            <a:off x="4251959" y="1097280"/>
+            <a:ext cx="3749039" cy="502920"/>
+          </a:xfrm>
+          <a:prstGeom prst="rect">
+            <a:avLst/>
+          </a:prstGeom>
+          <a:solidFill>
+            <a:srgbClr val="1565C0"/>
+          </a:solidFill>
+          <a:ln/>
+        </p:spPr>
+        <p:style>
+          <a:lnRef idx="1">
+            <a:schemeClr val="accent1"/>
+          </a:lnRef>
+          <a:fillRef idx="3">
+            <a:schemeClr val="accent1"/>
+          </a:fillRef>
+          <a:effectRef idx="2">
+            <a:schemeClr val="accent1"/>
+          </a:effectRef>
+          <a:fontRef idx="minor">
+            <a:schemeClr val="lt1"/>
+          </a:fontRef>
+        </p:style>
+        <p:txBody>
+          <a:bodyPr rtlCol="0" anchor="ctr"/>
+          <a:lstStyle/>
+          <a:p>
+            <a:pPr algn="ctr"/>
+          </a:p>
+        </p:txBody>
+      </p:sp>
+      <p:sp>
+        <p:nvSpPr>
+          <p:cNvPr id="13" name="TextBox 12"/>
+          <p:cNvSpPr txBox="1"/>
+          <p:nvPr/>
+        </p:nvSpPr>
+        <p:spPr>
+          <a:xfrm>
+            <a:off x="4343399" y="1143000"/>
+            <a:ext cx="3566160" cy="457200"/>
+          </a:xfrm>
+          <a:prstGeom prst="rect">
+            <a:avLst/>
+          </a:prstGeom>
+          <a:noFill/>
+        </p:spPr>
+        <p:txBody>
+          <a:bodyPr wrap="square">
+            <a:spAutoFit/>
+          </a:bodyPr>
+          <a:lstStyle/>
+          <a:p>
+            <a:pPr algn="l"/>
+            <a:r>
+              <a:rPr sz="1300" b="1" i="0">
+                <a:solidFill>
+                  <a:srgbClr val="FFFFFF"/>
+                </a:solidFill>
+                <a:latin typeface="Calibri"/>
+              </a:rPr>
+              <a:t>Eixo 2 — Remuneração</a:t>
+            </a:r>
+          </a:p>
+        </p:txBody>
+      </p:sp>
+      <p:sp>
+        <p:nvSpPr>
+          <p:cNvPr id="14" name="TextBox 13"/>
+          <p:cNvSpPr txBox="1"/>
+          <p:nvPr/>
+        </p:nvSpPr>
+        <p:spPr>
+          <a:xfrm>
+            <a:off x="4434839" y="1691640"/>
+            <a:ext cx="3383280" cy="731520"/>
+          </a:xfrm>
+          <a:prstGeom prst="rect">
+            <a:avLst/>
+          </a:prstGeom>
+          <a:noFill/>
+        </p:spPr>
+        <p:txBody>
+          <a:bodyPr wrap="square">
+            <a:spAutoFit/>
+          </a:bodyPr>
+          <a:lstStyle/>
+          <a:p>
+            <a:pPr algn="l"/>
+            <a:r>
+              <a:rPr sz="1200" b="0" i="0">
+                <a:solidFill>
+                  <a:srgbClr val="212121"/>
+                </a:solidFill>
+                <a:latin typeface="Calibri"/>
+              </a:rPr>
+              <a:t>▸  Transparência salarial por raça/gênero
+obrigatória (empresas &gt; 100 funcionários)</a:t>
+            </a:r>
+          </a:p>
+        </p:txBody>
+      </p:sp>
+      <p:sp>
+        <p:nvSpPr>
+          <p:cNvPr id="15" name="TextBox 14"/>
+          <p:cNvSpPr txBox="1"/>
+          <p:nvPr/>
+        </p:nvSpPr>
+        <p:spPr>
+          <a:xfrm>
+            <a:off x="4434839" y="2468880"/>
+            <a:ext cx="3383280" cy="731520"/>
+          </a:xfrm>
+          <a:prstGeom prst="rect">
+            <a:avLst/>
+          </a:prstGeom>
+          <a:noFill/>
+        </p:spPr>
+        <p:txBody>
+          <a:bodyPr wrap="square">
+            <a:spAutoFit/>
+          </a:bodyPr>
+          <a:lstStyle/>
+          <a:p>
+            <a:pPr algn="l"/>
+            <a:r>
+              <a:rPr sz="1200" b="0" i="0">
+                <a:solidFill>
+                  <a:srgbClr val="212121"/>
+                </a:solidFill>
+                <a:latin typeface="Calibri"/>
+              </a:rPr>
+              <a:t>▸  Auditoria de igual pagamento por trabalho igual
+com penalidades progressivas (gap HLM M4)</a:t>
+            </a:r>
+          </a:p>
+        </p:txBody>
+      </p:sp>
+      <p:sp>
+        <p:nvSpPr>
+          <p:cNvPr id="16" name="TextBox 15"/>
+          <p:cNvSpPr txBox="1"/>
+          <p:nvPr/>
+        </p:nvSpPr>
+        <p:spPr>
+          <a:xfrm>
+            <a:off x="4434839" y="3246120"/>
+            <a:ext cx="3383280" cy="731520"/>
+          </a:xfrm>
+          <a:prstGeom prst="rect">
+            <a:avLst/>
+          </a:prstGeom>
+          <a:noFill/>
+        </p:spPr>
+        <p:txBody>
+          <a:bodyPr wrap="square">
+            <a:spAutoFit/>
+          </a:bodyPr>
+          <a:lstStyle/>
+          <a:p>
+            <a:pPr algn="l"/>
+            <a:r>
+              <a:rPr sz="1200" b="0" i="0">
+                <a:solidFill>
+                  <a:srgbClr val="212121"/>
+                </a:solidFill>
+                <a:latin typeface="Calibri"/>
+              </a:rPr>
+              <a:t>▸  Piso salarial indexado nas categorias com
+maior gap racial residual (6,2% HLM M4)</a:t>
+            </a:r>
+          </a:p>
+        </p:txBody>
+      </p:sp>
+      <p:sp>
+        <p:nvSpPr>
+          <p:cNvPr id="17" name="Rectangle 16"/>
+          <p:cNvSpPr/>
+          <p:nvPr/>
+        </p:nvSpPr>
+        <p:spPr>
+          <a:xfrm>
+            <a:off x="8229598" y="1097280"/>
+            <a:ext cx="3749039" cy="5029200"/>
+          </a:xfrm>
+          <a:prstGeom prst="rect">
+            <a:avLst/>
+          </a:prstGeom>
+          <a:solidFill>
+            <a:srgbClr val="F5F5F5"/>
+          </a:solidFill>
+          <a:ln w="19050">
+            <a:solidFill>
+              <a:srgbClr val="2E7D32"/>
+            </a:solidFill>
+          </a:ln>
+        </p:spPr>
+        <p:style>
+          <a:lnRef idx="1">
+            <a:schemeClr val="accent1"/>
+          </a:lnRef>
+          <a:fillRef idx="3">
+            <a:schemeClr val="accent1"/>
+          </a:fillRef>
+          <a:effectRef idx="2">
+            <a:schemeClr val="accent1"/>
+          </a:effectRef>
+          <a:fontRef idx="minor">
+            <a:schemeClr val="lt1"/>
+          </a:fontRef>
+        </p:style>
+        <p:txBody>
+          <a:bodyPr rtlCol="0" anchor="ctr"/>
+          <a:lstStyle/>
+          <a:p>
+            <a:pPr algn="ctr"/>
+          </a:p>
+        </p:txBody>
+      </p:sp>
+      <p:sp>
+        <p:nvSpPr>
+          <p:cNvPr id="18" name="Rectangle 17"/>
+          <p:cNvSpPr/>
+          <p:nvPr/>
+        </p:nvSpPr>
+        <p:spPr>
+          <a:xfrm>
+            <a:off x="8229598" y="1097280"/>
+            <a:ext cx="3749039" cy="502920"/>
+          </a:xfrm>
+          <a:prstGeom prst="rect">
+            <a:avLst/>
+          </a:prstGeom>
+          <a:solidFill>
+            <a:srgbClr val="2E7D32"/>
+          </a:solidFill>
+          <a:ln/>
+        </p:spPr>
+        <p:style>
+          <a:lnRef idx="1">
+            <a:schemeClr val="accent1"/>
+          </a:lnRef>
+          <a:fillRef idx="3">
+            <a:schemeClr val="accent1"/>
+          </a:fillRef>
+          <a:effectRef idx="2">
+            <a:schemeClr val="accent1"/>
+          </a:effectRef>
+          <a:fontRef idx="minor">
+            <a:schemeClr val="lt1"/>
+          </a:fontRef>
+        </p:style>
+        <p:txBody>
+          <a:bodyPr rtlCol="0" anchor="ctr"/>
+          <a:lstStyle/>
+          <a:p>
+            <a:pPr algn="ctr"/>
+          </a:p>
+        </p:txBody>
+      </p:sp>
+      <p:sp>
+        <p:nvSpPr>
+          <p:cNvPr id="19" name="TextBox 18"/>
+          <p:cNvSpPr txBox="1"/>
+          <p:nvPr/>
+        </p:nvSpPr>
+        <p:spPr>
+          <a:xfrm>
+            <a:off x="8321038" y="1143000"/>
+            <a:ext cx="3566160" cy="457200"/>
+          </a:xfrm>
+          <a:prstGeom prst="rect">
+            <a:avLst/>
+          </a:prstGeom>
+          <a:noFill/>
+        </p:spPr>
+        <p:txBody>
+          <a:bodyPr wrap="square">
+            <a:spAutoFit/>
+          </a:bodyPr>
+          <a:lstStyle/>
+          <a:p>
+            <a:pPr algn="l"/>
+            <a:r>
+              <a:rPr sz="1300" b="1" i="0">
+                <a:solidFill>
+                  <a:srgbClr val="FFFFFF"/>
+                </a:solidFill>
+                <a:latin typeface="Calibri"/>
+              </a:rPr>
+              <a:t>Eixo 3 — Acesso a Ocupações</a:t>
+            </a:r>
+          </a:p>
+        </p:txBody>
+      </p:sp>
+      <p:sp>
+        <p:nvSpPr>
+          <p:cNvPr id="20" name="TextBox 19"/>
+          <p:cNvSpPr txBox="1"/>
+          <p:nvPr/>
+        </p:nvSpPr>
+        <p:spPr>
+          <a:xfrm>
+            <a:off x="8412478" y="1691640"/>
+            <a:ext cx="3383280" cy="731520"/>
+          </a:xfrm>
+          <a:prstGeom prst="rect">
+            <a:avLst/>
+          </a:prstGeom>
+          <a:noFill/>
+        </p:spPr>
+        <p:txBody>
+          <a:bodyPr wrap="square">
+            <a:spAutoFit/>
+          </a:bodyPr>
+          <a:lstStyle/>
+          <a:p>
+            <a:pPr algn="l"/>
+            <a:r>
+              <a:rPr sz="1200" b="0" i="0">
+                <a:solidFill>
+                  <a:srgbClr val="212121"/>
+                </a:solidFill>
+                <a:latin typeface="Calibri"/>
+              </a:rPr>
+              <a:t>▸  Mentoria e acesso a redes profissionais
+qualificadas para egressos negros</a:t>
+            </a:r>
+          </a:p>
+        </p:txBody>
+      </p:sp>
+      <p:sp>
+        <p:nvSpPr>
+          <p:cNvPr id="21" name="TextBox 20"/>
+          <p:cNvSpPr txBox="1"/>
+          <p:nvPr/>
+        </p:nvSpPr>
+        <p:spPr>
+          <a:xfrm>
+            <a:off x="8412478" y="2468880"/>
+            <a:ext cx="3383280" cy="731520"/>
+          </a:xfrm>
+          <a:prstGeom prst="rect">
+            <a:avLst/>
+          </a:prstGeom>
+          <a:noFill/>
+        </p:spPr>
+        <p:txBody>
+          <a:bodyPr wrap="square">
+            <a:spAutoFit/>
+          </a:bodyPr>
+          <a:lstStyle/>
+          <a:p>
+            <a:pPr algn="l"/>
+            <a:r>
+              <a:rPr sz="1200" b="0" i="0">
+                <a:solidFill>
+                  <a:srgbClr val="212121"/>
+                </a:solidFill>
+                <a:latin typeface="Calibri"/>
+              </a:rPr>
+              <a:t>▸  30% dos cargos DAS e liderança corporativa
+para negros até 2030</a:t>
+            </a:r>
+          </a:p>
+        </p:txBody>
+      </p:sp>
+      <p:sp>
+        <p:nvSpPr>
+          <p:cNvPr id="22" name="TextBox 21"/>
+          <p:cNvSpPr txBox="1"/>
+          <p:nvPr/>
+        </p:nvSpPr>
+        <p:spPr>
+          <a:xfrm>
+            <a:off x="8412478" y="3246120"/>
+            <a:ext cx="3383280" cy="731520"/>
+          </a:xfrm>
+          <a:prstGeom prst="rect">
+            <a:avLst/>
+          </a:prstGeom>
+          <a:noFill/>
+        </p:spPr>
+        <p:txBody>
+          <a:bodyPr wrap="square">
+            <a:spAutoFit/>
+          </a:bodyPr>
+          <a:lstStyle/>
+          <a:p>
+            <a:pPr algn="l"/>
+            <a:r>
+              <a:rPr sz="1200" b="0" i="0">
+                <a:solidFill>
+                  <a:srgbClr val="212121"/>
+                </a:solidFill>
+                <a:latin typeface="Calibri"/>
+              </a:rPr>
+              <a:t>▸  Ampliar acesso a ocupações qualificadas:
+principal canal do gap (Oaxaca + GLMM)</a:t>
+            </a:r>
+          </a:p>
+        </p:txBody>
+      </p:sp>
+      <p:sp>
+        <p:nvSpPr>
+          <p:cNvPr id="23" name="TextBox 22"/>
+          <p:cNvSpPr txBox="1"/>
+          <p:nvPr/>
+        </p:nvSpPr>
+        <p:spPr>
+          <a:xfrm>
+            <a:off x="274320" y="6217920"/>
+            <a:ext cx="11612880" cy="411480"/>
+          </a:xfrm>
+          <a:prstGeom prst="rect">
+            <a:avLst/>
+          </a:prstGeom>
+          <a:noFill/>
+        </p:spPr>
+        <p:txBody>
+          <a:bodyPr wrap="square">
+            <a:spAutoFit/>
+          </a:bodyPr>
+          <a:lstStyle/>
+          <a:p>
+            <a:pPr algn="ctr"/>
+            <a:r>
+              <a:rPr sz="1300" b="1" i="0">
+                <a:solidFill>
+                  <a:srgbClr val="B71C1C"/>
+                </a:solidFill>
+                <a:latin typeface="Calibri"/>
+              </a:rPr>
+              <a:t>⚠  Ao ritmo atual de convergência (~0,02 log-pontos/ano), eliminar o gap levaria mais de 100 anos.</a:t>
+            </a:r>
+          </a:p>
+        </p:txBody>
+      </p:sp>
+      <p:sp>
+        <p:nvSpPr>
+          <p:cNvPr id="24" name="Rectangle 23"/>
+          <p:cNvSpPr/>
+          <p:nvPr/>
+        </p:nvSpPr>
+        <p:spPr>
+          <a:xfrm>
+            <a:off x="0" y="6601968"/>
+            <a:ext cx="12188952" cy="256032"/>
+          </a:xfrm>
+          <a:prstGeom prst="rect">
+            <a:avLst/>
+          </a:prstGeom>
+          <a:solidFill>
+            <a:srgbClr val="1F3864"/>
+          </a:solidFill>
+          <a:ln/>
+        </p:spPr>
+        <p:style>
+          <a:lnRef idx="1">
+            <a:schemeClr val="accent1"/>
+          </a:lnRef>
+          <a:fillRef idx="3">
+            <a:schemeClr val="accent1"/>
+          </a:fillRef>
+          <a:effectRef idx="2">
+            <a:schemeClr val="accent1"/>
+          </a:effectRef>
+          <a:fontRef idx="minor">
+            <a:schemeClr val="lt1"/>
+          </a:fontRef>
+        </p:style>
+        <p:txBody>
+          <a:bodyPr rtlCol="0" anchor="ctr"/>
+          <a:lstStyle/>
+          <a:p>
+            <a:pPr algn="ctr"/>
+          </a:p>
+        </p:txBody>
+      </p:sp>
+      <p:sp>
+        <p:nvSpPr>
+          <p:cNvPr id="25" name="TextBox 24"/>
           <p:cNvSpPr txBox="1"/>
           <p:nvPr/>
         </p:nvSpPr>
@@ -12775,7 +12994,7 @@
       </p:sp>
       <p:sp>
         <p:nvSpPr>
-          <p:cNvPr id="11" name="TextBox 10"/>
+          <p:cNvPr id="26" name="TextBox 25"/>
           <p:cNvSpPr txBox="1"/>
           <p:nvPr/>
         </p:nvSpPr>
@@ -12803,7 +13022,7 @@
                 </a:solidFill>
                 <a:latin typeface="Calibri"/>
               </a:rPr>
-              <a:t>29/29</a:t>
+              <a:t>28/29</a:t>
             </a:r>
           </a:p>
         </p:txBody>
@@ -13470,6 +13689,587 @@
 </file>
 
 <file path=ppt/slides/slide20.xml><?xml version="1.0" encoding="utf-8"?>
+<p:sld xmlns:a="http://schemas.openxmlformats.org/drawingml/2006/main" xmlns:p="http://schemas.openxmlformats.org/presentationml/2006/main" xmlns:r="http://schemas.openxmlformats.org/officeDocument/2006/relationships">
+  <p:cSld>
+    <p:spTree>
+      <p:nvGrpSpPr>
+        <p:cNvPr id="1" name=""/>
+        <p:cNvGrpSpPr/>
+        <p:nvPr/>
+      </p:nvGrpSpPr>
+      <p:grpSpPr/>
+      <p:sp>
+        <p:nvSpPr>
+          <p:cNvPr id="2" name="Rectangle 1"/>
+          <p:cNvSpPr/>
+          <p:nvPr/>
+        </p:nvSpPr>
+        <p:spPr>
+          <a:xfrm>
+            <a:off x="0" y="0"/>
+            <a:ext cx="12188952" cy="1005840"/>
+          </a:xfrm>
+          <a:prstGeom prst="rect">
+            <a:avLst/>
+          </a:prstGeom>
+          <a:solidFill>
+            <a:srgbClr val="1F3864"/>
+          </a:solidFill>
+          <a:ln/>
+        </p:spPr>
+        <p:style>
+          <a:lnRef idx="1">
+            <a:schemeClr val="accent1"/>
+          </a:lnRef>
+          <a:fillRef idx="3">
+            <a:schemeClr val="accent1"/>
+          </a:fillRef>
+          <a:effectRef idx="2">
+            <a:schemeClr val="accent1"/>
+          </a:effectRef>
+          <a:fontRef idx="minor">
+            <a:schemeClr val="lt1"/>
+          </a:fontRef>
+        </p:style>
+        <p:txBody>
+          <a:bodyPr rtlCol="0" anchor="ctr"/>
+          <a:lstStyle/>
+          <a:p>
+            <a:pPr algn="ctr"/>
+          </a:p>
+        </p:txBody>
+      </p:sp>
+      <p:sp>
+        <p:nvSpPr>
+          <p:cNvPr id="3" name="TextBox 2"/>
+          <p:cNvSpPr txBox="1"/>
+          <p:nvPr/>
+        </p:nvSpPr>
+        <p:spPr>
+          <a:xfrm>
+            <a:off x="274320" y="73152"/>
+            <a:ext cx="10972800" cy="502920"/>
+          </a:xfrm>
+          <a:prstGeom prst="rect">
+            <a:avLst/>
+          </a:prstGeom>
+          <a:noFill/>
+        </p:spPr>
+        <p:txBody>
+          <a:bodyPr wrap="square">
+            <a:spAutoFit/>
+          </a:bodyPr>
+          <a:lstStyle/>
+          <a:p>
+            <a:pPr algn="l"/>
+            <a:r>
+              <a:rPr sz="2600" b="1" i="0">
+                <a:solidFill>
+                  <a:srgbClr val="FFFFFF"/>
+                </a:solidFill>
+                <a:latin typeface="Calibri"/>
+              </a:rPr>
+              <a:t>28. Limitações e Agenda Futura</a:t>
+            </a:r>
+          </a:p>
+        </p:txBody>
+      </p:sp>
+      <p:sp>
+        <p:nvSpPr>
+          <p:cNvPr id="4" name="TextBox 3"/>
+          <p:cNvSpPr txBox="1"/>
+          <p:nvPr/>
+        </p:nvSpPr>
+        <p:spPr>
+          <a:xfrm>
+            <a:off x="274320" y="594360"/>
+            <a:ext cx="10972800" cy="347472"/>
+          </a:xfrm>
+          <a:prstGeom prst="rect">
+            <a:avLst/>
+          </a:prstGeom>
+          <a:noFill/>
+        </p:spPr>
+        <p:txBody>
+          <a:bodyPr wrap="square">
+            <a:spAutoFit/>
+          </a:bodyPr>
+          <a:lstStyle/>
+          <a:p>
+            <a:pPr algn="l"/>
+            <a:r>
+              <a:rPr sz="1400" b="0" i="0">
+                <a:solidFill>
+                  <a:srgbClr val="BBDEFB"/>
+                </a:solidFill>
+                <a:latin typeface="Calibri"/>
+              </a:rPr>
+              <a:t>Honestidade acadêmica: o que este trabalho não faz e por quê</a:t>
+            </a:r>
+          </a:p>
+        </p:txBody>
+      </p:sp>
+      <p:sp>
+        <p:nvSpPr>
+          <p:cNvPr id="5" name="TextBox 4"/>
+          <p:cNvSpPr txBox="1"/>
+          <p:nvPr/>
+        </p:nvSpPr>
+        <p:spPr>
+          <a:xfrm>
+            <a:off x="365760" y="1143000"/>
+            <a:ext cx="5486400" cy="365760"/>
+          </a:xfrm>
+          <a:prstGeom prst="rect">
+            <a:avLst/>
+          </a:prstGeom>
+          <a:noFill/>
+        </p:spPr>
+        <p:txBody>
+          <a:bodyPr wrap="square">
+            <a:spAutoFit/>
+          </a:bodyPr>
+          <a:lstStyle/>
+          <a:p>
+            <a:pPr algn="l"/>
+            <a:r>
+              <a:rPr sz="1600" b="1" i="0">
+                <a:solidFill>
+                  <a:srgbClr val="B71C1C"/>
+                </a:solidFill>
+                <a:latin typeface="Calibri"/>
+              </a:rPr>
+              <a:t>Limitações</a:t>
+            </a:r>
+          </a:p>
+        </p:txBody>
+      </p:sp>
+      <p:sp>
+        <p:nvSpPr>
+          <p:cNvPr id="6" name="TextBox 5"/>
+          <p:cNvSpPr txBox="1"/>
+          <p:nvPr/>
+        </p:nvSpPr>
+        <p:spPr>
+          <a:xfrm>
+            <a:off x="365760" y="1600200"/>
+            <a:ext cx="5669280" cy="3474720"/>
+          </a:xfrm>
+          <a:prstGeom prst="rect">
+            <a:avLst/>
+          </a:prstGeom>
+          <a:noFill/>
+        </p:spPr>
+        <p:txBody>
+          <a:bodyPr wrap="square">
+            <a:spAutoFit/>
+          </a:bodyPr>
+          <a:lstStyle/>
+          <a:p>
+            <a:pPr>
+              <a:spcAft>
+                <a:spcPts val="400"/>
+              </a:spcAft>
+            </a:pPr>
+            <a:r>
+              <a:rPr sz="1300" b="1">
+                <a:solidFill>
+                  <a:srgbClr val="B71C1C"/>
+                </a:solidFill>
+                <a:latin typeface="Calibri"/>
+              </a:rPr>
+              <a:t>▸  </a:t>
+            </a:r>
+            <a:r>
+              <a:rPr sz="1300">
+                <a:solidFill>
+                  <a:srgbClr val="212121"/>
+                </a:solidFill>
+                <a:latin typeface="Calibri"/>
+              </a:rPr>
+              <a:t>PNAD não permite experimentos causais — coeficientes são associações condicionais, não efeitos causais no sentido de Rubin/Pearl</a:t>
+            </a:r>
+          </a:p>
+          <a:p>
+            <a:pPr>
+              <a:spcAft>
+                <a:spcPts val="400"/>
+              </a:spcAft>
+            </a:pPr>
+            <a:r>
+              <a:rPr sz="1300" b="1">
+                <a:solidFill>
+                  <a:srgbClr val="B71C1C"/>
+                </a:solidFill>
+                <a:latin typeface="Calibri"/>
+              </a:rPr>
+              <a:t>▸  </a:t>
+            </a:r>
+            <a:r>
+              <a:rPr sz="1300">
+                <a:solidFill>
+                  <a:srgbClr val="212121"/>
+                </a:solidFill>
+                <a:latin typeface="Calibri"/>
+              </a:rPr>
+              <a:t>UPA como proxy de bairro: unidade de amostragem ≠ bairro administrativo</a:t>
+            </a:r>
+          </a:p>
+          <a:p>
+            <a:pPr>
+              <a:spcAft>
+                <a:spcPts val="400"/>
+              </a:spcAft>
+            </a:pPr>
+            <a:r>
+              <a:rPr sz="1300" b="1">
+                <a:solidFill>
+                  <a:srgbClr val="B71C1C"/>
+                </a:solidFill>
+                <a:latin typeface="Calibri"/>
+              </a:rPr>
+              <a:t>▸  </a:t>
+            </a:r>
+            <a:r>
+              <a:rPr sz="1300">
+                <a:solidFill>
+                  <a:srgbClr val="212121"/>
+                </a:solidFill>
+                <a:latin typeface="Calibri"/>
+              </a:rPr>
+              <a:t>GLMM logístico estimado na PEA completa via lme4::glmer (nAGQ=0, bobyqa, n=7,7M, 40,9k UPAs), com efeito aleatório de UPA</a:t>
+            </a:r>
+          </a:p>
+          <a:p>
+            <a:pPr>
+              <a:spcAft>
+                <a:spcPts val="400"/>
+              </a:spcAft>
+            </a:pPr>
+            <a:r>
+              <a:rPr sz="1300" b="1">
+                <a:solidFill>
+                  <a:srgbClr val="B71C1C"/>
+                </a:solidFill>
+                <a:latin typeface="Calibri"/>
+              </a:rPr>
+              <a:t>▸  </a:t>
+            </a:r>
+            <a:r>
+              <a:rPr sz="1300">
+                <a:solidFill>
+                  <a:srgbClr val="212121"/>
+                </a:solidFill>
+                <a:latin typeface="Calibri"/>
+              </a:rPr>
+              <a:t>CBO auto-declarado pode ter viés de classificação por raça (deflation de ocupação)</a:t>
+            </a:r>
+          </a:p>
+        </p:txBody>
+      </p:sp>
+      <p:sp>
+        <p:nvSpPr>
+          <p:cNvPr id="7" name="TextBox 6"/>
+          <p:cNvSpPr txBox="1"/>
+          <p:nvPr/>
+        </p:nvSpPr>
+        <p:spPr>
+          <a:xfrm>
+            <a:off x="6400800" y="1143000"/>
+            <a:ext cx="5486400" cy="365760"/>
+          </a:xfrm>
+          <a:prstGeom prst="rect">
+            <a:avLst/>
+          </a:prstGeom>
+          <a:noFill/>
+        </p:spPr>
+        <p:txBody>
+          <a:bodyPr wrap="square">
+            <a:spAutoFit/>
+          </a:bodyPr>
+          <a:lstStyle/>
+          <a:p>
+            <a:pPr algn="l"/>
+            <a:r>
+              <a:rPr sz="1600" b="1" i="0">
+                <a:solidFill>
+                  <a:srgbClr val="1565C0"/>
+                </a:solidFill>
+                <a:latin typeface="Calibri"/>
+              </a:rPr>
+              <a:t>Agenda Futura</a:t>
+            </a:r>
+          </a:p>
+        </p:txBody>
+      </p:sp>
+      <p:sp>
+        <p:nvSpPr>
+          <p:cNvPr id="8" name="TextBox 7"/>
+          <p:cNvSpPr txBox="1"/>
+          <p:nvPr/>
+        </p:nvSpPr>
+        <p:spPr>
+          <a:xfrm>
+            <a:off x="6400800" y="1600200"/>
+            <a:ext cx="5669280" cy="3474720"/>
+          </a:xfrm>
+          <a:prstGeom prst="rect">
+            <a:avLst/>
+          </a:prstGeom>
+          <a:noFill/>
+        </p:spPr>
+        <p:txBody>
+          <a:bodyPr wrap="square">
+            <a:spAutoFit/>
+          </a:bodyPr>
+          <a:lstStyle/>
+          <a:p>
+            <a:pPr>
+              <a:spcAft>
+                <a:spcPts val="400"/>
+              </a:spcAft>
+            </a:pPr>
+            <a:r>
+              <a:rPr sz="1300" b="1">
+                <a:solidFill>
+                  <a:srgbClr val="1565C0"/>
+                </a:solidFill>
+                <a:latin typeface="Calibri"/>
+              </a:rPr>
+              <a:t>▸  </a:t>
+            </a:r>
+            <a:r>
+              <a:rPr sz="1300">
+                <a:solidFill>
+                  <a:srgbClr val="212121"/>
+                </a:solidFill>
+                <a:latin typeface="Calibri"/>
+              </a:rPr>
+              <a:t>Análise de variáveis instrumentais (IV) para identificação causal — distância à escola técnica como instrumento</a:t>
+            </a:r>
+          </a:p>
+          <a:p>
+            <a:pPr>
+              <a:spcAft>
+                <a:spcPts val="400"/>
+              </a:spcAft>
+            </a:pPr>
+            <a:r>
+              <a:rPr sz="1300" b="1">
+                <a:solidFill>
+                  <a:srgbClr val="1565C0"/>
+                </a:solidFill>
+                <a:latin typeface="Calibri"/>
+              </a:rPr>
+              <a:t>▸  </a:t>
+            </a:r>
+            <a:r>
+              <a:rPr sz="1300">
+                <a:solidFill>
+                  <a:srgbClr val="212121"/>
+                </a:solidFill>
+                <a:latin typeface="Calibri"/>
+              </a:rPr>
+              <a:t>RAIS linkada à PNAD para rastrear trajetórias de mobilidade intraempresa</a:t>
+            </a:r>
+          </a:p>
+          <a:p>
+            <a:pPr>
+              <a:spcAft>
+                <a:spcPts val="400"/>
+              </a:spcAft>
+            </a:pPr>
+            <a:r>
+              <a:rPr sz="1300" b="1">
+                <a:solidFill>
+                  <a:srgbClr val="1565C0"/>
+                </a:solidFill>
+                <a:latin typeface="Calibri"/>
+              </a:rPr>
+              <a:t>▸  </a:t>
+            </a:r>
+            <a:r>
+              <a:rPr sz="1300">
+                <a:solidFill>
+                  <a:srgbClr val="212121"/>
+                </a:solidFill>
+                <a:latin typeface="Calibri"/>
+              </a:rPr>
+              <a:t>Análise de mediação formal (path analysis) raça → ocupação → renda</a:t>
+            </a:r>
+          </a:p>
+          <a:p>
+            <a:pPr>
+              <a:spcAft>
+                <a:spcPts val="400"/>
+              </a:spcAft>
+            </a:pPr>
+            <a:r>
+              <a:rPr sz="1300" b="1">
+                <a:solidFill>
+                  <a:srgbClr val="1565C0"/>
+                </a:solidFill>
+                <a:latin typeface="Calibri"/>
+              </a:rPr>
+              <a:t>▸  </a:t>
+            </a:r>
+            <a:r>
+              <a:rPr sz="1300">
+                <a:solidFill>
+                  <a:srgbClr val="212121"/>
+                </a:solidFill>
+                <a:latin typeface="Calibri"/>
+              </a:rPr>
+              <a:t>Extensão ao setor público por UF — heterogeneidade do glass ceiling entre estados</a:t>
+            </a:r>
+          </a:p>
+          <a:p>
+            <a:pPr>
+              <a:spcAft>
+                <a:spcPts val="400"/>
+              </a:spcAft>
+            </a:pPr>
+            <a:r>
+              <a:rPr sz="1300" b="1">
+                <a:solidFill>
+                  <a:srgbClr val="1565C0"/>
+                </a:solidFill>
+                <a:latin typeface="Calibri"/>
+              </a:rPr>
+              <a:t>▸  </a:t>
+            </a:r>
+            <a:r>
+              <a:rPr sz="1300">
+                <a:solidFill>
+                  <a:srgbClr val="212121"/>
+                </a:solidFill>
+                <a:latin typeface="Calibri"/>
+              </a:rPr>
+              <a:t>Modelo longitudinal com painéis rotativos da PNAD (2T seguidos) para efeitos fixos de indivíduo</a:t>
+            </a:r>
+          </a:p>
+        </p:txBody>
+      </p:sp>
+      <p:sp>
+        <p:nvSpPr>
+          <p:cNvPr id="9" name="Rectangle 8"/>
+          <p:cNvSpPr/>
+          <p:nvPr/>
+        </p:nvSpPr>
+        <p:spPr>
+          <a:xfrm>
+            <a:off x="0" y="6601968"/>
+            <a:ext cx="12188952" cy="256032"/>
+          </a:xfrm>
+          <a:prstGeom prst="rect">
+            <a:avLst/>
+          </a:prstGeom>
+          <a:solidFill>
+            <a:srgbClr val="1F3864"/>
+          </a:solidFill>
+          <a:ln/>
+        </p:spPr>
+        <p:style>
+          <a:lnRef idx="1">
+            <a:schemeClr val="accent1"/>
+          </a:lnRef>
+          <a:fillRef idx="3">
+            <a:schemeClr val="accent1"/>
+          </a:fillRef>
+          <a:effectRef idx="2">
+            <a:schemeClr val="accent1"/>
+          </a:effectRef>
+          <a:fontRef idx="minor">
+            <a:schemeClr val="lt1"/>
+          </a:fontRef>
+        </p:style>
+        <p:txBody>
+          <a:bodyPr rtlCol="0" anchor="ctr"/>
+          <a:lstStyle/>
+          <a:p>
+            <a:pPr algn="ctr"/>
+          </a:p>
+        </p:txBody>
+      </p:sp>
+      <p:sp>
+        <p:nvSpPr>
+          <p:cNvPr id="10" name="TextBox 9"/>
+          <p:cNvSpPr txBox="1"/>
+          <p:nvPr/>
+        </p:nvSpPr>
+        <p:spPr>
+          <a:xfrm>
+            <a:off x="137160" y="6629400"/>
+            <a:ext cx="10058400" cy="228600"/>
+          </a:xfrm>
+          <a:prstGeom prst="rect">
+            <a:avLst/>
+          </a:prstGeom>
+          <a:noFill/>
+        </p:spPr>
+        <p:txBody>
+          <a:bodyPr wrap="square">
+            <a:spAutoFit/>
+          </a:bodyPr>
+          <a:lstStyle/>
+          <a:p>
+            <a:pPr algn="l"/>
+            <a:r>
+              <a:rPr sz="850" b="0" i="0">
+                <a:solidFill>
+                  <a:srgbClr val="BBDEFB"/>
+                </a:solidFill>
+                <a:latin typeface="Calibri"/>
+              </a:rPr>
+              <a:t>Ricardo Calheiros  |  MBA USP/ESALQ  |  Racismo Estrutural e Mercado de Trabalho</a:t>
+            </a:r>
+          </a:p>
+        </p:txBody>
+      </p:sp>
+      <p:sp>
+        <p:nvSpPr>
+          <p:cNvPr id="11" name="TextBox 10"/>
+          <p:cNvSpPr txBox="1"/>
+          <p:nvPr/>
+        </p:nvSpPr>
+        <p:spPr>
+          <a:xfrm>
+            <a:off x="11704320" y="6629400"/>
+            <a:ext cx="457200" cy="228600"/>
+          </a:xfrm>
+          <a:prstGeom prst="rect">
+            <a:avLst/>
+          </a:prstGeom>
+          <a:noFill/>
+        </p:spPr>
+        <p:txBody>
+          <a:bodyPr wrap="square">
+            <a:spAutoFit/>
+          </a:bodyPr>
+          <a:lstStyle/>
+          <a:p>
+            <a:pPr algn="r"/>
+            <a:r>
+              <a:rPr sz="850" b="0" i="0">
+                <a:solidFill>
+                  <a:srgbClr val="FFFFFF"/>
+                </a:solidFill>
+                <a:latin typeface="Calibri"/>
+              </a:rPr>
+              <a:t>29/29</a:t>
+            </a:r>
+          </a:p>
+        </p:txBody>
+      </p:sp>
+    </p:spTree>
+  </p:cSld>
+  <p:clrMapOvr>
+    <a:masterClrMapping/>
+  </p:clrMapOvr>
+</p:sld>
+</file>
+
+<file path=ppt/slides/slide21.xml><?xml version="1.0" encoding="utf-8"?>
 <p:sld xmlns:a="http://schemas.openxmlformats.org/drawingml/2006/main" xmlns:p="http://schemas.openxmlformats.org/presentationml/2006/main" xmlns:r="http://schemas.openxmlformats.org/officeDocument/2006/relationships">
   <p:cSld>
     <p:spTree>

</xml_diff>